<commit_message>
Mağaza okuma egzersizine grup aşaması eklendi
Çalışma kâğıdı üç sayfa oldu: bireysel kâğıt, grup kâğıdı, hoca notu.

Grup aşaması aynı görseli okuyan dört öğrenciyi bir araya getiriyor ve
uzlaşmaya değil, ayrışmayı kullanmaya zorluyor. Üç hamle:

1. Ayrışma haritası — nerede aynı, nerede farklı okuduk; çözmeden yaz
2. On iki kelimeden üçe — dört kişinin kelimeleri birleşir, kanıtı
   olmayan elenir; üç kelimede karar kılınır
3. Tek müdahale — üç kelimeyi güçlendirmek için mekânda değiştirilecek
   tek şey; kaba eskiz ve tek cümle, çözüm değil karar

Kâğıtta sunumda anlatılacak üç madde de yazılı, böylece dört sunum
karşılaştırılabilir oluyor. Hoca notuna grup aşamasında dikkat edilecek
dört madde eklendi (uzlaştırmama, kalemi en az konuşana verme,
"kaliteli" kelimesine müdahale, müdahale kutusunu küçük tutma).

Toplam süre ~105 dakika olarak güncellendi.

Co-Authored-By: Claude Opus 5 <noreply@anthropic.com>
Claude-Session: https://claude.ai/code/session_012829GnztWNW7AgpXkSZZYk
</commit_message>
<xml_diff>
--- a/magaza-tasarimi-dersi/Magaza-Okuma-Calisma-Kagidi.pptx
+++ b/magaza-tasarimi-dersi/Magaza-Okuma-Calisma-Kagidi.pptx
@@ -7,9 +7,10 @@
   <p:sldIdLst>
     <p:sldId id="256" r:id="rId2"/>
     <p:sldId id="257" r:id="rId3"/>
+    <p:sldId id="258" r:id="rId4"/>
   </p:sldIdLst>
   <p:notesMasterIdLst>
-    <p:notesMasterId r:id="rId4"/>
+    <p:notesMasterId r:id="rId5"/>
   </p:notesMasterIdLst>
   <p:sldSz cx="12192000" cy="6858000"/>
   <p:notesSz cx="6858000" cy="12192000"/>
@@ -591,7 +592,7 @@
           <a:p>
             <a:r>
               <a:rPr lang="en-US" dirty="0"/>
-              <a:t>Bu sayfayı öğrencilere dağıtmayın; kendinizde kalsın. Örnek satırı sadece sözlü olarak, ekrandaki beşinci görsel üzerinden gösterin.</a:t>
+              <a:t>Grup başına bir kâğıt. Kalemi grupta en az konuşan kişiye verin — bu, baskın öğrencinin kâğıdı ele geçirmesini engeller.</a:t>
             </a:r>
             <a:endParaRPr lang="en-US" dirty="0"/>
           </a:p>
@@ -615,6 +616,94 @@
             <a:fld id="{F7021451-1387-4CA6-816F-3879F97B5CBC}" type="slidenum">
               <a:rPr lang="en-US"/>
               <a:t>2</a:t>
+            </a:fld>
+            <a:endParaRPr lang="en-US"/>
+          </a:p>
+        </p:txBody>
+      </p:sp>
+    </p:spTree>
+    <p:extLst>
+      <p:ext uri="{BB962C8B-B14F-4D97-AF65-F5344CB8AC3E}">
+        <p14:creationId xmlns:p14="http://schemas.microsoft.com/office/powerpoint/2010/main" val="1024086991"/>
+      </p:ext>
+    </p:extLst>
+  </p:cSld>
+  <p:clrMapOvr>
+    <a:masterClrMapping/>
+  </p:clrMapOvr>
+</p:notes>
+</file>
+
+<file path=ppt/notesSlides/notesSlide3.xml><?xml version="1.0" encoding="utf-8"?>
+<p:notes xmlns:a="http://schemas.openxmlformats.org/drawingml/2006/main" xmlns:r="http://schemas.openxmlformats.org/officeDocument/2006/relationships" xmlns:p="http://schemas.openxmlformats.org/presentationml/2006/main">
+  <p:cSld>
+    <p:spTree>
+      <p:nvGrpSpPr>
+        <p:cNvPr id="1" name=""/>
+        <p:cNvGrpSpPr/>
+        <p:nvPr/>
+      </p:nvGrpSpPr>
+      <p:grpSpPr>
+        <a:xfrm>
+          <a:off x="0" y="0"/>
+          <a:ext cx="0" cy="0"/>
+          <a:chOff x="0" y="0"/>
+          <a:chExt cx="0" cy="0"/>
+        </a:xfrm>
+      </p:grpSpPr>
+      <p:sp>
+        <p:nvSpPr>
+          <p:cNvPr id="2" name="Slide Image Placeholder 1"/>
+          <p:cNvSpPr>
+            <a:spLocks noGrp="1" noRot="1" noChangeAspect="1"/>
+          </p:cNvSpPr>
+          <p:nvPr>
+            <p:ph type="sldImg"/>
+          </p:nvPr>
+        </p:nvSpPr>
+        <p:spPr/>
+      </p:sp>
+      <p:sp>
+        <p:nvSpPr>
+          <p:cNvPr id="3" name="Notes Placeholder 2"/>
+          <p:cNvSpPr>
+            <a:spLocks noGrp="1"/>
+          </p:cNvSpPr>
+          <p:nvPr>
+            <p:ph type="body" idx="1"/>
+          </p:nvPr>
+        </p:nvSpPr>
+        <p:spPr/>
+        <p:txBody>
+          <a:bodyPr/>
+          <a:lstStyle/>
+          <a:p>
+            <a:r>
+              <a:rPr lang="en-US" dirty="0"/>
+              <a:t>Bu sayfa öğrencilere dağıtılmaz.</a:t>
+            </a:r>
+            <a:endParaRPr lang="en-US" dirty="0"/>
+          </a:p>
+        </p:txBody>
+      </p:sp>
+      <p:sp>
+        <p:nvSpPr>
+          <p:cNvPr id="4" name="Slide Number Placeholder 3"/>
+          <p:cNvSpPr>
+            <a:spLocks noGrp="1"/>
+          </p:cNvSpPr>
+          <p:nvPr>
+            <p:ph type="sldNum" sz="quarter" idx="10"/>
+          </p:nvPr>
+        </p:nvSpPr>
+        <p:spPr/>
+        <p:txBody>
+          <a:bodyPr/>
+          <a:lstStyle/>
+          <a:p>
+            <a:fld id="{F7021451-1387-4CA6-816F-3879F97B5CBC}" type="slidenum">
+              <a:rPr lang="en-US"/>
+              <a:t>3</a:t>
             </a:fld>
             <a:endParaRPr lang="en-US"/>
           </a:p>
@@ -3107,24 +3196,24 @@
         </p:nvSpPr>
         <p:spPr>
           <a:xfrm>
-            <a:off x="548640" y="292608"/>
-            <a:ext cx="7315200" cy="457200"/>
-          </a:xfrm>
-          <a:prstGeom prst="rect">
-            <a:avLst/>
-          </a:prstGeom>
-          <a:noFill/>
-          <a:ln/>
-        </p:spPr>
-        <p:txBody>
-          <a:bodyPr wrap="square" lIns="0" tIns="0" rIns="0" bIns="0" rtlCol="0" anchor="ctr"/>
-          <a:lstStyle/>
-          <a:p>
-            <a:pPr indent="0" marL="0">
-              <a:buNone/>
-            </a:pPr>
-            <a:r>
-              <a:rPr lang="en-US" sz="2400" b="1" dirty="0">
+            <a:off x="548640" y="274320"/>
+            <a:ext cx="6400800" cy="457200"/>
+          </a:xfrm>
+          <a:prstGeom prst="rect">
+            <a:avLst/>
+          </a:prstGeom>
+          <a:noFill/>
+          <a:ln/>
+        </p:spPr>
+        <p:txBody>
+          <a:bodyPr wrap="square" lIns="0" tIns="0" rIns="0" bIns="0" rtlCol="0" anchor="ctr"/>
+          <a:lstStyle/>
+          <a:p>
+            <a:pPr indent="0" marL="0">
+              <a:buNone/>
+            </a:pPr>
+            <a:r>
+              <a:rPr lang="en-US" sz="2600" b="1" dirty="0">
                 <a:solidFill>
                   <a:srgbClr val="16161A"/>
                 </a:solidFill>
@@ -3132,9 +3221,9 @@
                 <a:ea typeface="Cambria" pitchFamily="34" charset="-122"/>
                 <a:cs typeface="Cambria" pitchFamily="34" charset="-120"/>
               </a:rPr>
-              <a:t>Egzersizi yönetme notu</a:t>
-            </a:r>
-            <a:endParaRPr lang="en-US" sz="2400" dirty="0"/>
+              <a:t>Aynı görsel, dört okuma</a:t>
+            </a:r>
+            <a:endParaRPr lang="en-US" sz="2600" dirty="0"/>
           </a:p>
         </p:txBody>
       </p:sp>
@@ -3146,8 +3235,8 @@
         </p:nvSpPr>
         <p:spPr>
           <a:xfrm>
-            <a:off x="548640" y="749808"/>
-            <a:ext cx="7315200" cy="256032"/>
+            <a:off x="548640" y="731520"/>
+            <a:ext cx="6949440" cy="274320"/>
           </a:xfrm>
           <a:prstGeom prst="rect">
             <a:avLst/>
@@ -3171,7 +3260,7 @@
                 <a:ea typeface="Calibri" pitchFamily="34" charset="-122"/>
                 <a:cs typeface="Calibri" pitchFamily="34" charset="-120"/>
               </a:rPr>
-              <a:t>Mağaza okuma  ·  75 dakika</a:t>
+              <a:t>Grup çalışması  ·  45 dakika  ·  Amaç uzlaşmak değil, ayrışmayı kullanmak</a:t>
             </a:r>
             <a:endParaRPr lang="en-US" sz="1050" dirty="0"/>
           </a:p>
@@ -3185,34 +3274,34 @@
         </p:nvSpPr>
         <p:spPr>
           <a:xfrm>
-            <a:off x="548640" y="1234440"/>
-            <a:ext cx="5120640" cy="237744"/>
-          </a:xfrm>
-          <a:prstGeom prst="rect">
-            <a:avLst/>
-          </a:prstGeom>
-          <a:noFill/>
-          <a:ln/>
-        </p:spPr>
-        <p:txBody>
-          <a:bodyPr wrap="square" lIns="0" tIns="0" rIns="0" bIns="0" rtlCol="0" anchor="ctr"/>
-          <a:lstStyle/>
-          <a:p>
-            <a:pPr indent="0" marL="0">
-              <a:buNone/>
-            </a:pPr>
-            <a:r>
-              <a:rPr lang="en-US" sz="900" b="1" spc="160" kern="0" dirty="0">
-                <a:solidFill>
-                  <a:srgbClr val="8C3A2B"/>
-                </a:solidFill>
-                <a:latin typeface="Calibri" pitchFamily="34" charset="0"/>
-                <a:ea typeface="Calibri" pitchFamily="34" charset="-122"/>
-                <a:cs typeface="Calibri" pitchFamily="34" charset="-120"/>
-              </a:rPr>
-              <a:t>GÖRSEL SEÇİM KRİTERLERİ</a:t>
-            </a:r>
-            <a:endParaRPr lang="en-US" sz="900" dirty="0"/>
+            <a:off x="7680960" y="310896"/>
+            <a:ext cx="1097280" cy="219456"/>
+          </a:xfrm>
+          <a:prstGeom prst="rect">
+            <a:avLst/>
+          </a:prstGeom>
+          <a:noFill/>
+          <a:ln/>
+        </p:spPr>
+        <p:txBody>
+          <a:bodyPr wrap="square" lIns="0" tIns="0" rIns="0" bIns="0" rtlCol="0" anchor="ctr"/>
+          <a:lstStyle/>
+          <a:p>
+            <a:pPr indent="0" marL="0">
+              <a:buNone/>
+            </a:pPr>
+            <a:r>
+              <a:rPr lang="en-US" sz="800" b="1" spc="140" kern="0" dirty="0">
+                <a:solidFill>
+                  <a:srgbClr val="A6A6AC"/>
+                </a:solidFill>
+                <a:latin typeface="Calibri" pitchFamily="34" charset="0"/>
+                <a:ea typeface="Calibri" pitchFamily="34" charset="-122"/>
+                <a:cs typeface="Calibri" pitchFamily="34" charset="-120"/>
+              </a:rPr>
+              <a:t>GÖRSEL NO</a:t>
+            </a:r>
+            <a:endParaRPr lang="en-US" sz="800" dirty="0"/>
           </a:p>
         </p:txBody>
       </p:sp>
@@ -3224,7 +3313,1821 @@
         </p:nvSpPr>
         <p:spPr>
           <a:xfrm>
-            <a:off x="612648" y="1545336"/>
+            <a:off x="8732520" y="530352"/>
+            <a:ext cx="685800" cy="0"/>
+          </a:xfrm>
+          <a:prstGeom prst="line">
+            <a:avLst/>
+          </a:prstGeom>
+          <a:noFill/>
+          <a:ln w="11430">
+            <a:solidFill>
+              <a:srgbClr val="7A7A82"/>
+            </a:solidFill>
+            <a:prstDash val="solid"/>
+          </a:ln>
+        </p:spPr>
+      </p:sp>
+      <p:sp>
+        <p:nvSpPr>
+          <p:cNvPr id="6" name="Text 4"/>
+          <p:cNvSpPr txBox="1"/>
+          <p:nvPr/>
+        </p:nvSpPr>
+        <p:spPr>
+          <a:xfrm>
+            <a:off x="9601200" y="310896"/>
+            <a:ext cx="1280160" cy="219456"/>
+          </a:xfrm>
+          <a:prstGeom prst="rect">
+            <a:avLst/>
+          </a:prstGeom>
+          <a:noFill/>
+          <a:ln/>
+        </p:spPr>
+        <p:txBody>
+          <a:bodyPr wrap="square" lIns="0" tIns="0" rIns="0" bIns="0" rtlCol="0" anchor="ctr"/>
+          <a:lstStyle/>
+          <a:p>
+            <a:pPr indent="0" marL="0">
+              <a:buNone/>
+            </a:pPr>
+            <a:r>
+              <a:rPr lang="en-US" sz="800" b="1" spc="140" kern="0" dirty="0">
+                <a:solidFill>
+                  <a:srgbClr val="A6A6AC"/>
+                </a:solidFill>
+                <a:latin typeface="Calibri" pitchFamily="34" charset="0"/>
+                <a:ea typeface="Calibri" pitchFamily="34" charset="-122"/>
+                <a:cs typeface="Calibri" pitchFamily="34" charset="-120"/>
+              </a:rPr>
+              <a:t>GRUP ÜYELERİ</a:t>
+            </a:r>
+            <a:endParaRPr lang="en-US" sz="800" dirty="0"/>
+          </a:p>
+        </p:txBody>
+      </p:sp>
+      <p:sp>
+        <p:nvSpPr>
+          <p:cNvPr id="7" name="Shape 5"/>
+          <p:cNvSpPr/>
+          <p:nvPr/>
+        </p:nvSpPr>
+        <p:spPr>
+          <a:xfrm>
+            <a:off x="9601200" y="530352"/>
+            <a:ext cx="2039112" cy="0"/>
+          </a:xfrm>
+          <a:prstGeom prst="line">
+            <a:avLst/>
+          </a:prstGeom>
+          <a:noFill/>
+          <a:ln w="11430">
+            <a:solidFill>
+              <a:srgbClr val="7A7A82"/>
+            </a:solidFill>
+            <a:prstDash val="solid"/>
+          </a:ln>
+        </p:spPr>
+      </p:sp>
+      <p:sp>
+        <p:nvSpPr>
+          <p:cNvPr id="8" name="Shape 6"/>
+          <p:cNvSpPr/>
+          <p:nvPr/>
+        </p:nvSpPr>
+        <p:spPr>
+          <a:xfrm>
+            <a:off x="9601200" y="768096"/>
+            <a:ext cx="2039112" cy="0"/>
+          </a:xfrm>
+          <a:prstGeom prst="line">
+            <a:avLst/>
+          </a:prstGeom>
+          <a:noFill/>
+          <a:ln w="9525">
+            <a:solidFill>
+              <a:srgbClr val="E4E4E8"/>
+            </a:solidFill>
+            <a:prstDash val="solid"/>
+          </a:ln>
+        </p:spPr>
+      </p:sp>
+      <p:sp>
+        <p:nvSpPr>
+          <p:cNvPr id="9" name="Shape 7"/>
+          <p:cNvSpPr/>
+          <p:nvPr/>
+        </p:nvSpPr>
+        <p:spPr>
+          <a:xfrm>
+            <a:off x="548640" y="1024128"/>
+            <a:ext cx="11091672" cy="1572768"/>
+          </a:xfrm>
+          <a:prstGeom prst="rect">
+            <a:avLst/>
+          </a:prstGeom>
+          <a:ln w="11430">
+            <a:solidFill>
+              <a:srgbClr val="C9C9CF"/>
+            </a:solidFill>
+            <a:prstDash val="solid"/>
+          </a:ln>
+        </p:spPr>
+      </p:sp>
+      <p:sp>
+        <p:nvSpPr>
+          <p:cNvPr id="10" name="Text 8"/>
+          <p:cNvSpPr txBox="1"/>
+          <p:nvPr/>
+        </p:nvSpPr>
+        <p:spPr>
+          <a:xfrm>
+            <a:off x="685800" y="1097280"/>
+            <a:ext cx="274320" cy="274320"/>
+          </a:xfrm>
+          <a:prstGeom prst="rect">
+            <a:avLst/>
+          </a:prstGeom>
+          <a:noFill/>
+          <a:ln/>
+        </p:spPr>
+        <p:txBody>
+          <a:bodyPr wrap="square" lIns="0" tIns="0" rIns="0" bIns="0" rtlCol="0" anchor="ctr"/>
+          <a:lstStyle/>
+          <a:p>
+            <a:pPr indent="0" marL="0">
+              <a:buNone/>
+            </a:pPr>
+            <a:r>
+              <a:rPr lang="en-US" sz="1500" b="1" dirty="0">
+                <a:solidFill>
+                  <a:srgbClr val="8C3A2B"/>
+                </a:solidFill>
+                <a:latin typeface="Cambria" pitchFamily="34" charset="0"/>
+                <a:ea typeface="Cambria" pitchFamily="34" charset="-122"/>
+                <a:cs typeface="Cambria" pitchFamily="34" charset="-120"/>
+              </a:rPr>
+              <a:t>1</a:t>
+            </a:r>
+            <a:endParaRPr lang="en-US" sz="1500" dirty="0"/>
+          </a:p>
+        </p:txBody>
+      </p:sp>
+      <p:sp>
+        <p:nvSpPr>
+          <p:cNvPr id="11" name="Text 9"/>
+          <p:cNvSpPr txBox="1"/>
+          <p:nvPr/>
+        </p:nvSpPr>
+        <p:spPr>
+          <a:xfrm>
+            <a:off x="1005840" y="1133856"/>
+            <a:ext cx="2743200" cy="219456"/>
+          </a:xfrm>
+          <a:prstGeom prst="rect">
+            <a:avLst/>
+          </a:prstGeom>
+          <a:noFill/>
+          <a:ln/>
+        </p:spPr>
+        <p:txBody>
+          <a:bodyPr wrap="square" lIns="0" tIns="0" rIns="0" bIns="0" rtlCol="0" anchor="ctr"/>
+          <a:lstStyle/>
+          <a:p>
+            <a:pPr indent="0" marL="0">
+              <a:buNone/>
+            </a:pPr>
+            <a:r>
+              <a:rPr lang="en-US" sz="900" b="1" spc="140" kern="0" dirty="0">
+                <a:solidFill>
+                  <a:srgbClr val="8C3A2B"/>
+                </a:solidFill>
+                <a:latin typeface="Calibri" pitchFamily="34" charset="0"/>
+                <a:ea typeface="Calibri" pitchFamily="34" charset="-122"/>
+                <a:cs typeface="Calibri" pitchFamily="34" charset="-120"/>
+              </a:rPr>
+              <a:t>AYRIŞMA HARİTASI</a:t>
+            </a:r>
+            <a:endParaRPr lang="en-US" sz="900" dirty="0"/>
+          </a:p>
+        </p:txBody>
+      </p:sp>
+      <p:sp>
+        <p:nvSpPr>
+          <p:cNvPr id="12" name="Text 10"/>
+          <p:cNvSpPr txBox="1"/>
+          <p:nvPr/>
+        </p:nvSpPr>
+        <p:spPr>
+          <a:xfrm>
+            <a:off x="3931920" y="1133856"/>
+            <a:ext cx="7589520" cy="219456"/>
+          </a:xfrm>
+          <a:prstGeom prst="rect">
+            <a:avLst/>
+          </a:prstGeom>
+          <a:noFill/>
+          <a:ln/>
+        </p:spPr>
+        <p:txBody>
+          <a:bodyPr wrap="square" lIns="0" tIns="0" rIns="0" bIns="0" rtlCol="0" anchor="ctr"/>
+          <a:lstStyle/>
+          <a:p>
+            <a:pPr indent="0" marL="0">
+              <a:buNone/>
+            </a:pPr>
+            <a:r>
+              <a:rPr lang="en-US" sz="900" i="1" dirty="0">
+                <a:solidFill>
+                  <a:srgbClr val="7A7A82"/>
+                </a:solidFill>
+                <a:latin typeface="Calibri" pitchFamily="34" charset="0"/>
+                <a:ea typeface="Calibri" pitchFamily="34" charset="-122"/>
+                <a:cs typeface="Calibri" pitchFamily="34" charset="-120"/>
+              </a:rPr>
+              <a:t>Dört kâğıdı yan yana koyun. Çözmeye çalışmayın — sadece nerede aynı, nerede farklı okuduğunuzu yazın.</a:t>
+            </a:r>
+            <a:endParaRPr lang="en-US" sz="900" dirty="0"/>
+          </a:p>
+        </p:txBody>
+      </p:sp>
+      <p:sp>
+        <p:nvSpPr>
+          <p:cNvPr id="13" name="Text 11"/>
+          <p:cNvSpPr txBox="1"/>
+          <p:nvPr/>
+        </p:nvSpPr>
+        <p:spPr>
+          <a:xfrm>
+            <a:off x="777240" y="1426464"/>
+            <a:ext cx="5029200" cy="201168"/>
+          </a:xfrm>
+          <a:prstGeom prst="rect">
+            <a:avLst/>
+          </a:prstGeom>
+          <a:noFill/>
+          <a:ln/>
+        </p:spPr>
+        <p:txBody>
+          <a:bodyPr wrap="square" lIns="0" tIns="0" rIns="0" bIns="0" rtlCol="0" anchor="ctr"/>
+          <a:lstStyle/>
+          <a:p>
+            <a:pPr indent="0" marL="0">
+              <a:buNone/>
+            </a:pPr>
+            <a:r>
+              <a:rPr lang="en-US" sz="800" b="1" spc="120" kern="0" dirty="0">
+                <a:solidFill>
+                  <a:srgbClr val="A6A6AC"/>
+                </a:solidFill>
+                <a:latin typeface="Calibri" pitchFamily="34" charset="0"/>
+                <a:ea typeface="Calibri" pitchFamily="34" charset="-122"/>
+                <a:cs typeface="Calibri" pitchFamily="34" charset="-120"/>
+              </a:rPr>
+              <a:t>DÖRDÜMÜZ DE AYNI ŞEYİ GÖRDÜK</a:t>
+            </a:r>
+            <a:endParaRPr lang="en-US" sz="800" dirty="0"/>
+          </a:p>
+        </p:txBody>
+      </p:sp>
+      <p:sp>
+        <p:nvSpPr>
+          <p:cNvPr id="14" name="Text 12"/>
+          <p:cNvSpPr txBox="1"/>
+          <p:nvPr/>
+        </p:nvSpPr>
+        <p:spPr>
+          <a:xfrm>
+            <a:off x="6355080" y="1426464"/>
+            <a:ext cx="5120640" cy="201168"/>
+          </a:xfrm>
+          <a:prstGeom prst="rect">
+            <a:avLst/>
+          </a:prstGeom>
+          <a:noFill/>
+          <a:ln/>
+        </p:spPr>
+        <p:txBody>
+          <a:bodyPr wrap="square" lIns="0" tIns="0" rIns="0" bIns="0" rtlCol="0" anchor="ctr"/>
+          <a:lstStyle/>
+          <a:p>
+            <a:pPr indent="0" marL="0">
+              <a:buNone/>
+            </a:pPr>
+            <a:r>
+              <a:rPr lang="en-US" sz="800" b="1" spc="120" kern="0" dirty="0">
+                <a:solidFill>
+                  <a:srgbClr val="8C3A2B"/>
+                </a:solidFill>
+                <a:latin typeface="Calibri" pitchFamily="34" charset="0"/>
+                <a:ea typeface="Calibri" pitchFamily="34" charset="-122"/>
+                <a:cs typeface="Calibri" pitchFamily="34" charset="-120"/>
+              </a:rPr>
+              <a:t>AYRI OKUDUĞUMUZ YERLER  —  ve her okumanın dayandığı kanıt</a:t>
+            </a:r>
+            <a:endParaRPr lang="en-US" sz="800" dirty="0"/>
+          </a:p>
+        </p:txBody>
+      </p:sp>
+      <p:sp>
+        <p:nvSpPr>
+          <p:cNvPr id="15" name="Shape 13"/>
+          <p:cNvSpPr/>
+          <p:nvPr/>
+        </p:nvSpPr>
+        <p:spPr>
+          <a:xfrm>
+            <a:off x="6144768" y="1371600"/>
+            <a:ext cx="0" cy="1133856"/>
+          </a:xfrm>
+          <a:prstGeom prst="line">
+            <a:avLst/>
+          </a:prstGeom>
+          <a:noFill/>
+          <a:ln w="11430">
+            <a:solidFill>
+              <a:srgbClr val="C9C9CF"/>
+            </a:solidFill>
+            <a:prstDash val="solid"/>
+          </a:ln>
+        </p:spPr>
+      </p:sp>
+      <p:sp>
+        <p:nvSpPr>
+          <p:cNvPr id="16" name="Shape 14"/>
+          <p:cNvSpPr/>
+          <p:nvPr/>
+        </p:nvSpPr>
+        <p:spPr>
+          <a:xfrm>
+            <a:off x="777240" y="1828800"/>
+            <a:ext cx="5166360" cy="0"/>
+          </a:xfrm>
+          <a:prstGeom prst="line">
+            <a:avLst/>
+          </a:prstGeom>
+          <a:noFill/>
+          <a:ln w="9525">
+            <a:solidFill>
+              <a:srgbClr val="E4E4E8"/>
+            </a:solidFill>
+            <a:prstDash val="solid"/>
+          </a:ln>
+        </p:spPr>
+      </p:sp>
+      <p:sp>
+        <p:nvSpPr>
+          <p:cNvPr id="17" name="Shape 15"/>
+          <p:cNvSpPr/>
+          <p:nvPr/>
+        </p:nvSpPr>
+        <p:spPr>
+          <a:xfrm>
+            <a:off x="6355080" y="1828800"/>
+            <a:ext cx="5074920" cy="0"/>
+          </a:xfrm>
+          <a:prstGeom prst="line">
+            <a:avLst/>
+          </a:prstGeom>
+          <a:noFill/>
+          <a:ln w="9525">
+            <a:solidFill>
+              <a:srgbClr val="E4E4E8"/>
+            </a:solidFill>
+            <a:prstDash val="solid"/>
+          </a:ln>
+        </p:spPr>
+      </p:sp>
+      <p:sp>
+        <p:nvSpPr>
+          <p:cNvPr id="18" name="Shape 16"/>
+          <p:cNvSpPr/>
+          <p:nvPr/>
+        </p:nvSpPr>
+        <p:spPr>
+          <a:xfrm>
+            <a:off x="777240" y="2057400"/>
+            <a:ext cx="5166360" cy="0"/>
+          </a:xfrm>
+          <a:prstGeom prst="line">
+            <a:avLst/>
+          </a:prstGeom>
+          <a:noFill/>
+          <a:ln w="9525">
+            <a:solidFill>
+              <a:srgbClr val="E4E4E8"/>
+            </a:solidFill>
+            <a:prstDash val="solid"/>
+          </a:ln>
+        </p:spPr>
+      </p:sp>
+      <p:sp>
+        <p:nvSpPr>
+          <p:cNvPr id="19" name="Shape 17"/>
+          <p:cNvSpPr/>
+          <p:nvPr/>
+        </p:nvSpPr>
+        <p:spPr>
+          <a:xfrm>
+            <a:off x="6355080" y="2057400"/>
+            <a:ext cx="5074920" cy="0"/>
+          </a:xfrm>
+          <a:prstGeom prst="line">
+            <a:avLst/>
+          </a:prstGeom>
+          <a:noFill/>
+          <a:ln w="9525">
+            <a:solidFill>
+              <a:srgbClr val="E4E4E8"/>
+            </a:solidFill>
+            <a:prstDash val="solid"/>
+          </a:ln>
+        </p:spPr>
+      </p:sp>
+      <p:sp>
+        <p:nvSpPr>
+          <p:cNvPr id="20" name="Shape 18"/>
+          <p:cNvSpPr/>
+          <p:nvPr/>
+        </p:nvSpPr>
+        <p:spPr>
+          <a:xfrm>
+            <a:off x="777240" y="2286000"/>
+            <a:ext cx="5166360" cy="0"/>
+          </a:xfrm>
+          <a:prstGeom prst="line">
+            <a:avLst/>
+          </a:prstGeom>
+          <a:noFill/>
+          <a:ln w="9525">
+            <a:solidFill>
+              <a:srgbClr val="E4E4E8"/>
+            </a:solidFill>
+            <a:prstDash val="solid"/>
+          </a:ln>
+        </p:spPr>
+      </p:sp>
+      <p:sp>
+        <p:nvSpPr>
+          <p:cNvPr id="21" name="Shape 19"/>
+          <p:cNvSpPr/>
+          <p:nvPr/>
+        </p:nvSpPr>
+        <p:spPr>
+          <a:xfrm>
+            <a:off x="6355080" y="2286000"/>
+            <a:ext cx="5074920" cy="0"/>
+          </a:xfrm>
+          <a:prstGeom prst="line">
+            <a:avLst/>
+          </a:prstGeom>
+          <a:noFill/>
+          <a:ln w="9525">
+            <a:solidFill>
+              <a:srgbClr val="E4E4E8"/>
+            </a:solidFill>
+            <a:prstDash val="solid"/>
+          </a:ln>
+        </p:spPr>
+      </p:sp>
+      <p:sp>
+        <p:nvSpPr>
+          <p:cNvPr id="22" name="Shape 20"/>
+          <p:cNvSpPr/>
+          <p:nvPr/>
+        </p:nvSpPr>
+        <p:spPr>
+          <a:xfrm>
+            <a:off x="548640" y="2724912"/>
+            <a:ext cx="6675120" cy="2286000"/>
+          </a:xfrm>
+          <a:prstGeom prst="rect">
+            <a:avLst/>
+          </a:prstGeom>
+          <a:ln w="11430">
+            <a:solidFill>
+              <a:srgbClr val="C9C9CF"/>
+            </a:solidFill>
+            <a:prstDash val="solid"/>
+          </a:ln>
+        </p:spPr>
+      </p:sp>
+      <p:sp>
+        <p:nvSpPr>
+          <p:cNvPr id="23" name="Text 21"/>
+          <p:cNvSpPr txBox="1"/>
+          <p:nvPr/>
+        </p:nvSpPr>
+        <p:spPr>
+          <a:xfrm>
+            <a:off x="685800" y="2798064"/>
+            <a:ext cx="274320" cy="274320"/>
+          </a:xfrm>
+          <a:prstGeom prst="rect">
+            <a:avLst/>
+          </a:prstGeom>
+          <a:noFill/>
+          <a:ln/>
+        </p:spPr>
+        <p:txBody>
+          <a:bodyPr wrap="square" lIns="0" tIns="0" rIns="0" bIns="0" rtlCol="0" anchor="ctr"/>
+          <a:lstStyle/>
+          <a:p>
+            <a:pPr indent="0" marL="0">
+              <a:buNone/>
+            </a:pPr>
+            <a:r>
+              <a:rPr lang="en-US" sz="1500" b="1" dirty="0">
+                <a:solidFill>
+                  <a:srgbClr val="8C3A2B"/>
+                </a:solidFill>
+                <a:latin typeface="Cambria" pitchFamily="34" charset="0"/>
+                <a:ea typeface="Cambria" pitchFamily="34" charset="-122"/>
+                <a:cs typeface="Cambria" pitchFamily="34" charset="-120"/>
+              </a:rPr>
+              <a:t>2</a:t>
+            </a:r>
+            <a:endParaRPr lang="en-US" sz="1500" dirty="0"/>
+          </a:p>
+        </p:txBody>
+      </p:sp>
+      <p:sp>
+        <p:nvSpPr>
+          <p:cNvPr id="24" name="Text 22"/>
+          <p:cNvSpPr txBox="1"/>
+          <p:nvPr/>
+        </p:nvSpPr>
+        <p:spPr>
+          <a:xfrm>
+            <a:off x="1005840" y="2834640"/>
+            <a:ext cx="2926080" cy="219456"/>
+          </a:xfrm>
+          <a:prstGeom prst="rect">
+            <a:avLst/>
+          </a:prstGeom>
+          <a:noFill/>
+          <a:ln/>
+        </p:spPr>
+        <p:txBody>
+          <a:bodyPr wrap="square" lIns="0" tIns="0" rIns="0" bIns="0" rtlCol="0" anchor="ctr"/>
+          <a:lstStyle/>
+          <a:p>
+            <a:pPr indent="0" marL="0">
+              <a:buNone/>
+            </a:pPr>
+            <a:r>
+              <a:rPr lang="en-US" sz="900" b="1" spc="140" kern="0" dirty="0">
+                <a:solidFill>
+                  <a:srgbClr val="8C3A2B"/>
+                </a:solidFill>
+                <a:latin typeface="Calibri" pitchFamily="34" charset="0"/>
+                <a:ea typeface="Calibri" pitchFamily="34" charset="-122"/>
+                <a:cs typeface="Calibri" pitchFamily="34" charset="-120"/>
+              </a:rPr>
+              <a:t>ON İKİ KELİMEDEN ÜÇE</a:t>
+            </a:r>
+            <a:endParaRPr lang="en-US" sz="900" dirty="0"/>
+          </a:p>
+        </p:txBody>
+      </p:sp>
+      <p:sp>
+        <p:nvSpPr>
+          <p:cNvPr id="25" name="Text 23"/>
+          <p:cNvSpPr txBox="1"/>
+          <p:nvPr/>
+        </p:nvSpPr>
+        <p:spPr>
+          <a:xfrm>
+            <a:off x="777240" y="3090672"/>
+            <a:ext cx="6217920" cy="219456"/>
+          </a:xfrm>
+          <a:prstGeom prst="rect">
+            <a:avLst/>
+          </a:prstGeom>
+          <a:noFill/>
+          <a:ln/>
+        </p:spPr>
+        <p:txBody>
+          <a:bodyPr wrap="square" lIns="0" tIns="0" rIns="0" bIns="0" rtlCol="0" anchor="ctr"/>
+          <a:lstStyle/>
+          <a:p>
+            <a:pPr indent="0" marL="0">
+              <a:buNone/>
+            </a:pPr>
+            <a:r>
+              <a:rPr lang="en-US" sz="850" i="1" dirty="0">
+                <a:solidFill>
+                  <a:srgbClr val="7A7A82"/>
+                </a:solidFill>
+                <a:latin typeface="Calibri" pitchFamily="34" charset="0"/>
+                <a:ea typeface="Calibri" pitchFamily="34" charset="-122"/>
+                <a:cs typeface="Calibri" pitchFamily="34" charset="-120"/>
+              </a:rPr>
+              <a:t>Dördünüzün kelimelerini birleştirin, sonra üçe indirin. Kanıtı olmayan kelime elenir.</a:t>
+            </a:r>
+            <a:endParaRPr lang="en-US" sz="850" dirty="0"/>
+          </a:p>
+        </p:txBody>
+      </p:sp>
+      <p:sp>
+        <p:nvSpPr>
+          <p:cNvPr id="26" name="Text 24"/>
+          <p:cNvSpPr txBox="1"/>
+          <p:nvPr/>
+        </p:nvSpPr>
+        <p:spPr>
+          <a:xfrm>
+            <a:off x="777240" y="3346704"/>
+            <a:ext cx="731520" cy="182880"/>
+          </a:xfrm>
+          <a:prstGeom prst="rect">
+            <a:avLst/>
+          </a:prstGeom>
+          <a:noFill/>
+          <a:ln/>
+        </p:spPr>
+        <p:txBody>
+          <a:bodyPr wrap="square" lIns="0" tIns="0" rIns="0" bIns="0" rtlCol="0" anchor="ctr"/>
+          <a:lstStyle/>
+          <a:p>
+            <a:pPr indent="0" marL="0">
+              <a:buNone/>
+            </a:pPr>
+            <a:r>
+              <a:rPr lang="en-US" sz="750" b="1" spc="120" kern="0" dirty="0">
+                <a:solidFill>
+                  <a:srgbClr val="A6A6AC"/>
+                </a:solidFill>
+                <a:latin typeface="Calibri" pitchFamily="34" charset="0"/>
+                <a:ea typeface="Calibri" pitchFamily="34" charset="-122"/>
+                <a:cs typeface="Calibri" pitchFamily="34" charset="-120"/>
+              </a:rPr>
+              <a:t>HAVUZ</a:t>
+            </a:r>
+            <a:endParaRPr lang="en-US" sz="750" dirty="0"/>
+          </a:p>
+        </p:txBody>
+      </p:sp>
+      <p:sp>
+        <p:nvSpPr>
+          <p:cNvPr id="27" name="Shape 25"/>
+          <p:cNvSpPr/>
+          <p:nvPr/>
+        </p:nvSpPr>
+        <p:spPr>
+          <a:xfrm>
+            <a:off x="1554480" y="3511296"/>
+            <a:ext cx="5440680" cy="0"/>
+          </a:xfrm>
+          <a:prstGeom prst="line">
+            <a:avLst/>
+          </a:prstGeom>
+          <a:noFill/>
+          <a:ln w="9525">
+            <a:solidFill>
+              <a:srgbClr val="E4E4E8"/>
+            </a:solidFill>
+            <a:prstDash val="solid"/>
+          </a:ln>
+        </p:spPr>
+      </p:sp>
+      <p:sp>
+        <p:nvSpPr>
+          <p:cNvPr id="28" name="Text 26"/>
+          <p:cNvSpPr txBox="1"/>
+          <p:nvPr/>
+        </p:nvSpPr>
+        <p:spPr>
+          <a:xfrm>
+            <a:off x="777240" y="3694176"/>
+            <a:ext cx="228600" cy="219456"/>
+          </a:xfrm>
+          <a:prstGeom prst="rect">
+            <a:avLst/>
+          </a:prstGeom>
+          <a:noFill/>
+          <a:ln/>
+        </p:spPr>
+        <p:txBody>
+          <a:bodyPr wrap="square" lIns="0" tIns="0" rIns="0" bIns="0" rtlCol="0" anchor="ctr"/>
+          <a:lstStyle/>
+          <a:p>
+            <a:pPr indent="0" marL="0">
+              <a:buNone/>
+            </a:pPr>
+            <a:r>
+              <a:rPr lang="en-US" sz="1200" b="1" dirty="0">
+                <a:solidFill>
+                  <a:srgbClr val="A6A6AC"/>
+                </a:solidFill>
+                <a:latin typeface="Cambria" pitchFamily="34" charset="0"/>
+                <a:ea typeface="Cambria" pitchFamily="34" charset="-122"/>
+                <a:cs typeface="Cambria" pitchFamily="34" charset="-120"/>
+              </a:rPr>
+              <a:t>1</a:t>
+            </a:r>
+            <a:endParaRPr lang="en-US" sz="1200" dirty="0"/>
+          </a:p>
+        </p:txBody>
+      </p:sp>
+      <p:sp>
+        <p:nvSpPr>
+          <p:cNvPr id="29" name="Shape 27"/>
+          <p:cNvSpPr/>
+          <p:nvPr/>
+        </p:nvSpPr>
+        <p:spPr>
+          <a:xfrm>
+            <a:off x="1051560" y="3913632"/>
+            <a:ext cx="2148840" cy="0"/>
+          </a:xfrm>
+          <a:prstGeom prst="line">
+            <a:avLst/>
+          </a:prstGeom>
+          <a:noFill/>
+          <a:ln w="11430">
+            <a:solidFill>
+              <a:srgbClr val="7A7A82"/>
+            </a:solidFill>
+            <a:prstDash val="solid"/>
+          </a:ln>
+        </p:spPr>
+      </p:sp>
+      <p:sp>
+        <p:nvSpPr>
+          <p:cNvPr id="30" name="Text 28"/>
+          <p:cNvSpPr txBox="1"/>
+          <p:nvPr/>
+        </p:nvSpPr>
+        <p:spPr>
+          <a:xfrm>
+            <a:off x="3310128" y="3712464"/>
+            <a:ext cx="457200" cy="182880"/>
+          </a:xfrm>
+          <a:prstGeom prst="rect">
+            <a:avLst/>
+          </a:prstGeom>
+          <a:noFill/>
+          <a:ln/>
+        </p:spPr>
+        <p:txBody>
+          <a:bodyPr wrap="square" lIns="0" tIns="0" rIns="0" bIns="0" rtlCol="0" anchor="ctr"/>
+          <a:lstStyle/>
+          <a:p>
+            <a:pPr indent="0" marL="0">
+              <a:buNone/>
+            </a:pPr>
+            <a:r>
+              <a:rPr lang="en-US" sz="750" i="1" dirty="0">
+                <a:solidFill>
+                  <a:srgbClr val="A6A6AC"/>
+                </a:solidFill>
+                <a:latin typeface="Calibri" pitchFamily="34" charset="0"/>
+                <a:ea typeface="Calibri" pitchFamily="34" charset="-122"/>
+                <a:cs typeface="Calibri" pitchFamily="34" charset="-120"/>
+              </a:rPr>
+              <a:t>kanıt</a:t>
+            </a:r>
+            <a:endParaRPr lang="en-US" sz="750" dirty="0"/>
+          </a:p>
+        </p:txBody>
+      </p:sp>
+      <p:sp>
+        <p:nvSpPr>
+          <p:cNvPr id="31" name="Shape 29"/>
+          <p:cNvSpPr/>
+          <p:nvPr/>
+        </p:nvSpPr>
+        <p:spPr>
+          <a:xfrm>
+            <a:off x="3794760" y="3913632"/>
+            <a:ext cx="3200400" cy="0"/>
+          </a:xfrm>
+          <a:prstGeom prst="line">
+            <a:avLst/>
+          </a:prstGeom>
+          <a:noFill/>
+          <a:ln w="9525">
+            <a:solidFill>
+              <a:srgbClr val="E4E4E8"/>
+            </a:solidFill>
+            <a:prstDash val="solid"/>
+          </a:ln>
+        </p:spPr>
+      </p:sp>
+      <p:sp>
+        <p:nvSpPr>
+          <p:cNvPr id="32" name="Text 30"/>
+          <p:cNvSpPr txBox="1"/>
+          <p:nvPr/>
+        </p:nvSpPr>
+        <p:spPr>
+          <a:xfrm>
+            <a:off x="777240" y="4114800"/>
+            <a:ext cx="228600" cy="219456"/>
+          </a:xfrm>
+          <a:prstGeom prst="rect">
+            <a:avLst/>
+          </a:prstGeom>
+          <a:noFill/>
+          <a:ln/>
+        </p:spPr>
+        <p:txBody>
+          <a:bodyPr wrap="square" lIns="0" tIns="0" rIns="0" bIns="0" rtlCol="0" anchor="ctr"/>
+          <a:lstStyle/>
+          <a:p>
+            <a:pPr indent="0" marL="0">
+              <a:buNone/>
+            </a:pPr>
+            <a:r>
+              <a:rPr lang="en-US" sz="1200" b="1" dirty="0">
+                <a:solidFill>
+                  <a:srgbClr val="A6A6AC"/>
+                </a:solidFill>
+                <a:latin typeface="Cambria" pitchFamily="34" charset="0"/>
+                <a:ea typeface="Cambria" pitchFamily="34" charset="-122"/>
+                <a:cs typeface="Cambria" pitchFamily="34" charset="-120"/>
+              </a:rPr>
+              <a:t>2</a:t>
+            </a:r>
+            <a:endParaRPr lang="en-US" sz="1200" dirty="0"/>
+          </a:p>
+        </p:txBody>
+      </p:sp>
+      <p:sp>
+        <p:nvSpPr>
+          <p:cNvPr id="33" name="Shape 31"/>
+          <p:cNvSpPr/>
+          <p:nvPr/>
+        </p:nvSpPr>
+        <p:spPr>
+          <a:xfrm>
+            <a:off x="1051560" y="4334256"/>
+            <a:ext cx="2148840" cy="0"/>
+          </a:xfrm>
+          <a:prstGeom prst="line">
+            <a:avLst/>
+          </a:prstGeom>
+          <a:noFill/>
+          <a:ln w="11430">
+            <a:solidFill>
+              <a:srgbClr val="7A7A82"/>
+            </a:solidFill>
+            <a:prstDash val="solid"/>
+          </a:ln>
+        </p:spPr>
+      </p:sp>
+      <p:sp>
+        <p:nvSpPr>
+          <p:cNvPr id="34" name="Text 32"/>
+          <p:cNvSpPr txBox="1"/>
+          <p:nvPr/>
+        </p:nvSpPr>
+        <p:spPr>
+          <a:xfrm>
+            <a:off x="3310128" y="4133088"/>
+            <a:ext cx="457200" cy="182880"/>
+          </a:xfrm>
+          <a:prstGeom prst="rect">
+            <a:avLst/>
+          </a:prstGeom>
+          <a:noFill/>
+          <a:ln/>
+        </p:spPr>
+        <p:txBody>
+          <a:bodyPr wrap="square" lIns="0" tIns="0" rIns="0" bIns="0" rtlCol="0" anchor="ctr"/>
+          <a:lstStyle/>
+          <a:p>
+            <a:pPr indent="0" marL="0">
+              <a:buNone/>
+            </a:pPr>
+            <a:r>
+              <a:rPr lang="en-US" sz="750" i="1" dirty="0">
+                <a:solidFill>
+                  <a:srgbClr val="A6A6AC"/>
+                </a:solidFill>
+                <a:latin typeface="Calibri" pitchFamily="34" charset="0"/>
+                <a:ea typeface="Calibri" pitchFamily="34" charset="-122"/>
+                <a:cs typeface="Calibri" pitchFamily="34" charset="-120"/>
+              </a:rPr>
+              <a:t>kanıt</a:t>
+            </a:r>
+            <a:endParaRPr lang="en-US" sz="750" dirty="0"/>
+          </a:p>
+        </p:txBody>
+      </p:sp>
+      <p:sp>
+        <p:nvSpPr>
+          <p:cNvPr id="35" name="Shape 33"/>
+          <p:cNvSpPr/>
+          <p:nvPr/>
+        </p:nvSpPr>
+        <p:spPr>
+          <a:xfrm>
+            <a:off x="3794760" y="4334256"/>
+            <a:ext cx="3200400" cy="0"/>
+          </a:xfrm>
+          <a:prstGeom prst="line">
+            <a:avLst/>
+          </a:prstGeom>
+          <a:noFill/>
+          <a:ln w="9525">
+            <a:solidFill>
+              <a:srgbClr val="E4E4E8"/>
+            </a:solidFill>
+            <a:prstDash val="solid"/>
+          </a:ln>
+        </p:spPr>
+      </p:sp>
+      <p:sp>
+        <p:nvSpPr>
+          <p:cNvPr id="36" name="Text 34"/>
+          <p:cNvSpPr txBox="1"/>
+          <p:nvPr/>
+        </p:nvSpPr>
+        <p:spPr>
+          <a:xfrm>
+            <a:off x="777240" y="4535424"/>
+            <a:ext cx="228600" cy="219456"/>
+          </a:xfrm>
+          <a:prstGeom prst="rect">
+            <a:avLst/>
+          </a:prstGeom>
+          <a:noFill/>
+          <a:ln/>
+        </p:spPr>
+        <p:txBody>
+          <a:bodyPr wrap="square" lIns="0" tIns="0" rIns="0" bIns="0" rtlCol="0" anchor="ctr"/>
+          <a:lstStyle/>
+          <a:p>
+            <a:pPr indent="0" marL="0">
+              <a:buNone/>
+            </a:pPr>
+            <a:r>
+              <a:rPr lang="en-US" sz="1200" b="1" dirty="0">
+                <a:solidFill>
+                  <a:srgbClr val="A6A6AC"/>
+                </a:solidFill>
+                <a:latin typeface="Cambria" pitchFamily="34" charset="0"/>
+                <a:ea typeface="Cambria" pitchFamily="34" charset="-122"/>
+                <a:cs typeface="Cambria" pitchFamily="34" charset="-120"/>
+              </a:rPr>
+              <a:t>3</a:t>
+            </a:r>
+            <a:endParaRPr lang="en-US" sz="1200" dirty="0"/>
+          </a:p>
+        </p:txBody>
+      </p:sp>
+      <p:sp>
+        <p:nvSpPr>
+          <p:cNvPr id="37" name="Shape 35"/>
+          <p:cNvSpPr/>
+          <p:nvPr/>
+        </p:nvSpPr>
+        <p:spPr>
+          <a:xfrm>
+            <a:off x="1051560" y="4754880"/>
+            <a:ext cx="2148840" cy="0"/>
+          </a:xfrm>
+          <a:prstGeom prst="line">
+            <a:avLst/>
+          </a:prstGeom>
+          <a:noFill/>
+          <a:ln w="11430">
+            <a:solidFill>
+              <a:srgbClr val="7A7A82"/>
+            </a:solidFill>
+            <a:prstDash val="solid"/>
+          </a:ln>
+        </p:spPr>
+      </p:sp>
+      <p:sp>
+        <p:nvSpPr>
+          <p:cNvPr id="38" name="Text 36"/>
+          <p:cNvSpPr txBox="1"/>
+          <p:nvPr/>
+        </p:nvSpPr>
+        <p:spPr>
+          <a:xfrm>
+            <a:off x="3310128" y="4553712"/>
+            <a:ext cx="457200" cy="182880"/>
+          </a:xfrm>
+          <a:prstGeom prst="rect">
+            <a:avLst/>
+          </a:prstGeom>
+          <a:noFill/>
+          <a:ln/>
+        </p:spPr>
+        <p:txBody>
+          <a:bodyPr wrap="square" lIns="0" tIns="0" rIns="0" bIns="0" rtlCol="0" anchor="ctr"/>
+          <a:lstStyle/>
+          <a:p>
+            <a:pPr indent="0" marL="0">
+              <a:buNone/>
+            </a:pPr>
+            <a:r>
+              <a:rPr lang="en-US" sz="750" i="1" dirty="0">
+                <a:solidFill>
+                  <a:srgbClr val="A6A6AC"/>
+                </a:solidFill>
+                <a:latin typeface="Calibri" pitchFamily="34" charset="0"/>
+                <a:ea typeface="Calibri" pitchFamily="34" charset="-122"/>
+                <a:cs typeface="Calibri" pitchFamily="34" charset="-120"/>
+              </a:rPr>
+              <a:t>kanıt</a:t>
+            </a:r>
+            <a:endParaRPr lang="en-US" sz="750" dirty="0"/>
+          </a:p>
+        </p:txBody>
+      </p:sp>
+      <p:sp>
+        <p:nvSpPr>
+          <p:cNvPr id="39" name="Shape 37"/>
+          <p:cNvSpPr/>
+          <p:nvPr/>
+        </p:nvSpPr>
+        <p:spPr>
+          <a:xfrm>
+            <a:off x="3794760" y="4754880"/>
+            <a:ext cx="3200400" cy="0"/>
+          </a:xfrm>
+          <a:prstGeom prst="line">
+            <a:avLst/>
+          </a:prstGeom>
+          <a:noFill/>
+          <a:ln w="9525">
+            <a:solidFill>
+              <a:srgbClr val="E4E4E8"/>
+            </a:solidFill>
+            <a:prstDash val="solid"/>
+          </a:ln>
+        </p:spPr>
+      </p:sp>
+      <p:sp>
+        <p:nvSpPr>
+          <p:cNvPr id="40" name="Shape 38"/>
+          <p:cNvSpPr/>
+          <p:nvPr/>
+        </p:nvSpPr>
+        <p:spPr>
+          <a:xfrm>
+            <a:off x="7498080" y="2724912"/>
+            <a:ext cx="4142232" cy="2286000"/>
+          </a:xfrm>
+          <a:prstGeom prst="rect">
+            <a:avLst/>
+          </a:prstGeom>
+          <a:solidFill>
+            <a:srgbClr val="F6EAE6"/>
+          </a:solidFill>
+          <a:ln w="13970">
+            <a:solidFill>
+              <a:srgbClr val="8C3A2B"/>
+            </a:solidFill>
+            <a:prstDash val="solid"/>
+          </a:ln>
+        </p:spPr>
+      </p:sp>
+      <p:sp>
+        <p:nvSpPr>
+          <p:cNvPr id="41" name="Text 39"/>
+          <p:cNvSpPr txBox="1"/>
+          <p:nvPr/>
+        </p:nvSpPr>
+        <p:spPr>
+          <a:xfrm>
+            <a:off x="7635240" y="2798064"/>
+            <a:ext cx="274320" cy="274320"/>
+          </a:xfrm>
+          <a:prstGeom prst="rect">
+            <a:avLst/>
+          </a:prstGeom>
+          <a:noFill/>
+          <a:ln/>
+        </p:spPr>
+        <p:txBody>
+          <a:bodyPr wrap="square" lIns="0" tIns="0" rIns="0" bIns="0" rtlCol="0" anchor="ctr"/>
+          <a:lstStyle/>
+          <a:p>
+            <a:pPr indent="0" marL="0">
+              <a:buNone/>
+            </a:pPr>
+            <a:r>
+              <a:rPr lang="en-US" sz="1500" b="1" dirty="0">
+                <a:solidFill>
+                  <a:srgbClr val="8C3A2B"/>
+                </a:solidFill>
+                <a:latin typeface="Cambria" pitchFamily="34" charset="0"/>
+                <a:ea typeface="Cambria" pitchFamily="34" charset="-122"/>
+                <a:cs typeface="Cambria" pitchFamily="34" charset="-120"/>
+              </a:rPr>
+              <a:t>3</a:t>
+            </a:r>
+            <a:endParaRPr lang="en-US" sz="1500" dirty="0"/>
+          </a:p>
+        </p:txBody>
+      </p:sp>
+      <p:sp>
+        <p:nvSpPr>
+          <p:cNvPr id="42" name="Text 40"/>
+          <p:cNvSpPr txBox="1"/>
+          <p:nvPr/>
+        </p:nvSpPr>
+        <p:spPr>
+          <a:xfrm>
+            <a:off x="7955280" y="2834640"/>
+            <a:ext cx="2743200" cy="219456"/>
+          </a:xfrm>
+          <a:prstGeom prst="rect">
+            <a:avLst/>
+          </a:prstGeom>
+          <a:noFill/>
+          <a:ln/>
+        </p:spPr>
+        <p:txBody>
+          <a:bodyPr wrap="square" lIns="0" tIns="0" rIns="0" bIns="0" rtlCol="0" anchor="ctr"/>
+          <a:lstStyle/>
+          <a:p>
+            <a:pPr indent="0" marL="0">
+              <a:buNone/>
+            </a:pPr>
+            <a:r>
+              <a:rPr lang="en-US" sz="900" b="1" spc="140" kern="0" dirty="0">
+                <a:solidFill>
+                  <a:srgbClr val="8C3A2B"/>
+                </a:solidFill>
+                <a:latin typeface="Calibri" pitchFamily="34" charset="0"/>
+                <a:ea typeface="Calibri" pitchFamily="34" charset="-122"/>
+                <a:cs typeface="Calibri" pitchFamily="34" charset="-120"/>
+              </a:rPr>
+              <a:t>TEK MÜDAHALE</a:t>
+            </a:r>
+            <a:endParaRPr lang="en-US" sz="900" dirty="0"/>
+          </a:p>
+        </p:txBody>
+      </p:sp>
+      <p:sp>
+        <p:nvSpPr>
+          <p:cNvPr id="43" name="Text 41"/>
+          <p:cNvSpPr txBox="1"/>
+          <p:nvPr/>
+        </p:nvSpPr>
+        <p:spPr>
+          <a:xfrm>
+            <a:off x="7726680" y="3090672"/>
+            <a:ext cx="3685032" cy="566928"/>
+          </a:xfrm>
+          <a:prstGeom prst="rect">
+            <a:avLst/>
+          </a:prstGeom>
+          <a:noFill/>
+          <a:ln/>
+        </p:spPr>
+        <p:txBody>
+          <a:bodyPr wrap="square" lIns="0" tIns="0" rIns="0" bIns="0" rtlCol="0" anchor="ctr"/>
+          <a:lstStyle/>
+          <a:p>
+            <a:pPr indent="0" marL="0">
+              <a:lnSpc>
+                <a:spcPts val="1050"/>
+              </a:lnSpc>
+              <a:buNone/>
+            </a:pPr>
+            <a:r>
+              <a:rPr lang="en-US" sz="850" i="1" dirty="0">
+                <a:solidFill>
+                  <a:srgbClr val="7A7A82"/>
+                </a:solidFill>
+                <a:latin typeface="Calibri" pitchFamily="34" charset="0"/>
+                <a:ea typeface="Calibri" pitchFamily="34" charset="-122"/>
+                <a:cs typeface="Calibri" pitchFamily="34" charset="-120"/>
+              </a:rPr>
+              <a:t>Üç kelimenizi daha güçlü kılmak için bu mekânda tek bir şeyi değiştirebilseydiniz, neyi değiştirirdiniz? Kaba eskiz + tek cümle. Çözüm değil, karar.</a:t>
+            </a:r>
+            <a:endParaRPr lang="en-US" sz="850" dirty="0"/>
+          </a:p>
+        </p:txBody>
+      </p:sp>
+      <p:sp>
+        <p:nvSpPr>
+          <p:cNvPr id="44" name="Shape 42"/>
+          <p:cNvSpPr/>
+          <p:nvPr/>
+        </p:nvSpPr>
+        <p:spPr>
+          <a:xfrm>
+            <a:off x="7726680" y="4791456"/>
+            <a:ext cx="3685032" cy="0"/>
+          </a:xfrm>
+          <a:prstGeom prst="line">
+            <a:avLst/>
+          </a:prstGeom>
+          <a:noFill/>
+          <a:ln w="11430">
+            <a:solidFill>
+              <a:srgbClr val="7A7A82"/>
+            </a:solidFill>
+            <a:prstDash val="solid"/>
+          </a:ln>
+        </p:spPr>
+      </p:sp>
+      <p:sp>
+        <p:nvSpPr>
+          <p:cNvPr id="45" name="Text 43"/>
+          <p:cNvSpPr txBox="1"/>
+          <p:nvPr/>
+        </p:nvSpPr>
+        <p:spPr>
+          <a:xfrm>
+            <a:off x="548640" y="5175504"/>
+            <a:ext cx="5486400" cy="219456"/>
+          </a:xfrm>
+          <a:prstGeom prst="rect">
+            <a:avLst/>
+          </a:prstGeom>
+          <a:noFill/>
+          <a:ln/>
+        </p:spPr>
+        <p:txBody>
+          <a:bodyPr wrap="square" lIns="0" tIns="0" rIns="0" bIns="0" rtlCol="0" anchor="ctr"/>
+          <a:lstStyle/>
+          <a:p>
+            <a:pPr indent="0" marL="0">
+              <a:buNone/>
+            </a:pPr>
+            <a:r>
+              <a:rPr lang="en-US" sz="900" b="1" spc="140" kern="0" dirty="0">
+                <a:solidFill>
+                  <a:srgbClr val="8C3A2B"/>
+                </a:solidFill>
+                <a:latin typeface="Calibri" pitchFamily="34" charset="0"/>
+                <a:ea typeface="Calibri" pitchFamily="34" charset="-122"/>
+                <a:cs typeface="Calibri" pitchFamily="34" charset="-120"/>
+              </a:rPr>
+              <a:t>SUNUMDA ANLATACAĞINIZ ÜÇ ŞEY  ·  4 DAKİKA</a:t>
+            </a:r>
+            <a:endParaRPr lang="en-US" sz="900" dirty="0"/>
+          </a:p>
+        </p:txBody>
+      </p:sp>
+      <p:sp>
+        <p:nvSpPr>
+          <p:cNvPr id="46" name="Text 44"/>
+          <p:cNvSpPr txBox="1"/>
+          <p:nvPr/>
+        </p:nvSpPr>
+        <p:spPr>
+          <a:xfrm>
+            <a:off x="548640" y="5468112"/>
+            <a:ext cx="228600" cy="219456"/>
+          </a:xfrm>
+          <a:prstGeom prst="rect">
+            <a:avLst/>
+          </a:prstGeom>
+          <a:noFill/>
+          <a:ln/>
+        </p:spPr>
+        <p:txBody>
+          <a:bodyPr wrap="square" lIns="0" tIns="0" rIns="0" bIns="0" rtlCol="0" anchor="ctr"/>
+          <a:lstStyle/>
+          <a:p>
+            <a:pPr indent="0" marL="0">
+              <a:buNone/>
+            </a:pPr>
+            <a:r>
+              <a:rPr lang="en-US" sz="1200" b="1" dirty="0">
+                <a:solidFill>
+                  <a:srgbClr val="8C3A2B"/>
+                </a:solidFill>
+                <a:latin typeface="Cambria" pitchFamily="34" charset="0"/>
+                <a:ea typeface="Cambria" pitchFamily="34" charset="-122"/>
+                <a:cs typeface="Cambria" pitchFamily="34" charset="-120"/>
+              </a:rPr>
+              <a:t>1</a:t>
+            </a:r>
+            <a:endParaRPr lang="en-US" sz="1200" dirty="0"/>
+          </a:p>
+        </p:txBody>
+      </p:sp>
+      <p:sp>
+        <p:nvSpPr>
+          <p:cNvPr id="47" name="Text 45"/>
+          <p:cNvSpPr txBox="1"/>
+          <p:nvPr/>
+        </p:nvSpPr>
+        <p:spPr>
+          <a:xfrm>
+            <a:off x="822960" y="5468112"/>
+            <a:ext cx="3200400" cy="219456"/>
+          </a:xfrm>
+          <a:prstGeom prst="rect">
+            <a:avLst/>
+          </a:prstGeom>
+          <a:noFill/>
+          <a:ln/>
+        </p:spPr>
+        <p:txBody>
+          <a:bodyPr wrap="square" lIns="0" tIns="0" rIns="0" bIns="0" rtlCol="0" anchor="ctr"/>
+          <a:lstStyle/>
+          <a:p>
+            <a:pPr indent="0" marL="0">
+              <a:buNone/>
+            </a:pPr>
+            <a:r>
+              <a:rPr lang="en-US" sz="1000" b="1" dirty="0">
+                <a:solidFill>
+                  <a:srgbClr val="16161A"/>
+                </a:solidFill>
+                <a:latin typeface="Calibri" pitchFamily="34" charset="0"/>
+                <a:ea typeface="Calibri" pitchFamily="34" charset="-122"/>
+                <a:cs typeface="Calibri" pitchFamily="34" charset="-120"/>
+              </a:rPr>
+              <a:t>Plan tahmini</a:t>
+            </a:r>
+            <a:endParaRPr lang="en-US" sz="1000" dirty="0"/>
+          </a:p>
+        </p:txBody>
+      </p:sp>
+      <p:sp>
+        <p:nvSpPr>
+          <p:cNvPr id="48" name="Text 46"/>
+          <p:cNvSpPr txBox="1"/>
+          <p:nvPr/>
+        </p:nvSpPr>
+        <p:spPr>
+          <a:xfrm>
+            <a:off x="822960" y="5687568"/>
+            <a:ext cx="3246120" cy="502920"/>
+          </a:xfrm>
+          <a:prstGeom prst="rect">
+            <a:avLst/>
+          </a:prstGeom>
+          <a:noFill/>
+          <a:ln/>
+        </p:spPr>
+        <p:txBody>
+          <a:bodyPr wrap="square" lIns="0" tIns="0" rIns="0" bIns="0" rtlCol="0" anchor="ctr"/>
+          <a:lstStyle/>
+          <a:p>
+            <a:pPr indent="0" marL="0">
+              <a:lnSpc>
+                <a:spcPts val="1150"/>
+              </a:lnSpc>
+              <a:buNone/>
+            </a:pPr>
+            <a:r>
+              <a:rPr lang="en-US" sz="900" dirty="0">
+                <a:solidFill>
+                  <a:srgbClr val="7A7A82"/>
+                </a:solidFill>
+                <a:latin typeface="Calibri" pitchFamily="34" charset="0"/>
+                <a:ea typeface="Calibri" pitchFamily="34" charset="-122"/>
+                <a:cs typeface="Calibri" pitchFamily="34" charset="-120"/>
+              </a:rPr>
+              <a:t>Dört eskizden hangisini seçtiniz ya da nasıl birleştirdiniz — ve neden.</a:t>
+            </a:r>
+            <a:endParaRPr lang="en-US" sz="900" dirty="0"/>
+          </a:p>
+        </p:txBody>
+      </p:sp>
+      <p:sp>
+        <p:nvSpPr>
+          <p:cNvPr id="49" name="Text 47"/>
+          <p:cNvSpPr txBox="1"/>
+          <p:nvPr/>
+        </p:nvSpPr>
+        <p:spPr>
+          <a:xfrm>
+            <a:off x="4315968" y="5468112"/>
+            <a:ext cx="228600" cy="219456"/>
+          </a:xfrm>
+          <a:prstGeom prst="rect">
+            <a:avLst/>
+          </a:prstGeom>
+          <a:noFill/>
+          <a:ln/>
+        </p:spPr>
+        <p:txBody>
+          <a:bodyPr wrap="square" lIns="0" tIns="0" rIns="0" bIns="0" rtlCol="0" anchor="ctr"/>
+          <a:lstStyle/>
+          <a:p>
+            <a:pPr indent="0" marL="0">
+              <a:buNone/>
+            </a:pPr>
+            <a:r>
+              <a:rPr lang="en-US" sz="1200" b="1" dirty="0">
+                <a:solidFill>
+                  <a:srgbClr val="8C3A2B"/>
+                </a:solidFill>
+                <a:latin typeface="Cambria" pitchFamily="34" charset="0"/>
+                <a:ea typeface="Cambria" pitchFamily="34" charset="-122"/>
+                <a:cs typeface="Cambria" pitchFamily="34" charset="-120"/>
+              </a:rPr>
+              <a:t>2</a:t>
+            </a:r>
+            <a:endParaRPr lang="en-US" sz="1200" dirty="0"/>
+          </a:p>
+        </p:txBody>
+      </p:sp>
+      <p:sp>
+        <p:nvSpPr>
+          <p:cNvPr id="50" name="Text 48"/>
+          <p:cNvSpPr txBox="1"/>
+          <p:nvPr/>
+        </p:nvSpPr>
+        <p:spPr>
+          <a:xfrm>
+            <a:off x="4590288" y="5468112"/>
+            <a:ext cx="3200400" cy="219456"/>
+          </a:xfrm>
+          <a:prstGeom prst="rect">
+            <a:avLst/>
+          </a:prstGeom>
+          <a:noFill/>
+          <a:ln/>
+        </p:spPr>
+        <p:txBody>
+          <a:bodyPr wrap="square" lIns="0" tIns="0" rIns="0" bIns="0" rtlCol="0" anchor="ctr"/>
+          <a:lstStyle/>
+          <a:p>
+            <a:pPr indent="0" marL="0">
+              <a:buNone/>
+            </a:pPr>
+            <a:r>
+              <a:rPr lang="en-US" sz="1000" b="1" dirty="0">
+                <a:solidFill>
+                  <a:srgbClr val="16161A"/>
+                </a:solidFill>
+                <a:latin typeface="Calibri" pitchFamily="34" charset="0"/>
+                <a:ea typeface="Calibri" pitchFamily="34" charset="-122"/>
+                <a:cs typeface="Calibri" pitchFamily="34" charset="-120"/>
+              </a:rPr>
+              <a:t>Üç kelime</a:t>
+            </a:r>
+            <a:endParaRPr lang="en-US" sz="1000" dirty="0"/>
+          </a:p>
+        </p:txBody>
+      </p:sp>
+      <p:sp>
+        <p:nvSpPr>
+          <p:cNvPr id="51" name="Text 49"/>
+          <p:cNvSpPr txBox="1"/>
+          <p:nvPr/>
+        </p:nvSpPr>
+        <p:spPr>
+          <a:xfrm>
+            <a:off x="4590288" y="5687568"/>
+            <a:ext cx="3246120" cy="502920"/>
+          </a:xfrm>
+          <a:prstGeom prst="rect">
+            <a:avLst/>
+          </a:prstGeom>
+          <a:noFill/>
+          <a:ln/>
+        </p:spPr>
+        <p:txBody>
+          <a:bodyPr wrap="square" lIns="0" tIns="0" rIns="0" bIns="0" rtlCol="0" anchor="ctr"/>
+          <a:lstStyle/>
+          <a:p>
+            <a:pPr indent="0" marL="0">
+              <a:lnSpc>
+                <a:spcPts val="1150"/>
+              </a:lnSpc>
+              <a:buNone/>
+            </a:pPr>
+            <a:r>
+              <a:rPr lang="en-US" sz="900" dirty="0">
+                <a:solidFill>
+                  <a:srgbClr val="7A7A82"/>
+                </a:solidFill>
+                <a:latin typeface="Calibri" pitchFamily="34" charset="0"/>
+                <a:ea typeface="Calibri" pitchFamily="34" charset="-122"/>
+                <a:cs typeface="Calibri" pitchFamily="34" charset="-120"/>
+              </a:rPr>
+              <a:t>Her kelimenin görseldeki kanıtı. Elenen kelimelerden birini de söyleyin, neden elendi.</a:t>
+            </a:r>
+            <a:endParaRPr lang="en-US" sz="900" dirty="0"/>
+          </a:p>
+        </p:txBody>
+      </p:sp>
+      <p:sp>
+        <p:nvSpPr>
+          <p:cNvPr id="52" name="Text 50"/>
+          <p:cNvSpPr txBox="1"/>
+          <p:nvPr/>
+        </p:nvSpPr>
+        <p:spPr>
+          <a:xfrm>
+            <a:off x="8083296" y="5468112"/>
+            <a:ext cx="228600" cy="219456"/>
+          </a:xfrm>
+          <a:prstGeom prst="rect">
+            <a:avLst/>
+          </a:prstGeom>
+          <a:noFill/>
+          <a:ln/>
+        </p:spPr>
+        <p:txBody>
+          <a:bodyPr wrap="square" lIns="0" tIns="0" rIns="0" bIns="0" rtlCol="0" anchor="ctr"/>
+          <a:lstStyle/>
+          <a:p>
+            <a:pPr indent="0" marL="0">
+              <a:buNone/>
+            </a:pPr>
+            <a:r>
+              <a:rPr lang="en-US" sz="1200" b="1" dirty="0">
+                <a:solidFill>
+                  <a:srgbClr val="8C3A2B"/>
+                </a:solidFill>
+                <a:latin typeface="Cambria" pitchFamily="34" charset="0"/>
+                <a:ea typeface="Cambria" pitchFamily="34" charset="-122"/>
+                <a:cs typeface="Cambria" pitchFamily="34" charset="-120"/>
+              </a:rPr>
+              <a:t>3</a:t>
+            </a:r>
+            <a:endParaRPr lang="en-US" sz="1200" dirty="0"/>
+          </a:p>
+        </p:txBody>
+      </p:sp>
+      <p:sp>
+        <p:nvSpPr>
+          <p:cNvPr id="53" name="Text 51"/>
+          <p:cNvSpPr txBox="1"/>
+          <p:nvPr/>
+        </p:nvSpPr>
+        <p:spPr>
+          <a:xfrm>
+            <a:off x="8357616" y="5468112"/>
+            <a:ext cx="3200400" cy="219456"/>
+          </a:xfrm>
+          <a:prstGeom prst="rect">
+            <a:avLst/>
+          </a:prstGeom>
+          <a:noFill/>
+          <a:ln/>
+        </p:spPr>
+        <p:txBody>
+          <a:bodyPr wrap="square" lIns="0" tIns="0" rIns="0" bIns="0" rtlCol="0" anchor="ctr"/>
+          <a:lstStyle/>
+          <a:p>
+            <a:pPr indent="0" marL="0">
+              <a:buNone/>
+            </a:pPr>
+            <a:r>
+              <a:rPr lang="en-US" sz="1000" b="1" dirty="0">
+                <a:solidFill>
+                  <a:srgbClr val="16161A"/>
+                </a:solidFill>
+                <a:latin typeface="Calibri" pitchFamily="34" charset="0"/>
+                <a:ea typeface="Calibri" pitchFamily="34" charset="-122"/>
+                <a:cs typeface="Calibri" pitchFamily="34" charset="-120"/>
+              </a:rPr>
+              <a:t>Tek müdahale</a:t>
+            </a:r>
+            <a:endParaRPr lang="en-US" sz="1000" dirty="0"/>
+          </a:p>
+        </p:txBody>
+      </p:sp>
+      <p:sp>
+        <p:nvSpPr>
+          <p:cNvPr id="54" name="Text 52"/>
+          <p:cNvSpPr txBox="1"/>
+          <p:nvPr/>
+        </p:nvSpPr>
+        <p:spPr>
+          <a:xfrm>
+            <a:off x="8357616" y="5687568"/>
+            <a:ext cx="3246120" cy="502920"/>
+          </a:xfrm>
+          <a:prstGeom prst="rect">
+            <a:avLst/>
+          </a:prstGeom>
+          <a:noFill/>
+          <a:ln/>
+        </p:spPr>
+        <p:txBody>
+          <a:bodyPr wrap="square" lIns="0" tIns="0" rIns="0" bIns="0" rtlCol="0" anchor="ctr"/>
+          <a:lstStyle/>
+          <a:p>
+            <a:pPr indent="0" marL="0">
+              <a:lnSpc>
+                <a:spcPts val="1150"/>
+              </a:lnSpc>
+              <a:buNone/>
+            </a:pPr>
+            <a:r>
+              <a:rPr lang="en-US" sz="900" dirty="0">
+                <a:solidFill>
+                  <a:srgbClr val="7A7A82"/>
+                </a:solidFill>
+                <a:latin typeface="Calibri" pitchFamily="34" charset="0"/>
+                <a:ea typeface="Calibri" pitchFamily="34" charset="-122"/>
+                <a:cs typeface="Calibri" pitchFamily="34" charset="-120"/>
+              </a:rPr>
+              <a:t>Ne değiştirdiniz, hangi kelimeyi güçlendirmek için.</a:t>
+            </a:r>
+            <a:endParaRPr lang="en-US" sz="900" dirty="0"/>
+          </a:p>
+        </p:txBody>
+      </p:sp>
+      <p:sp>
+        <p:nvSpPr>
+          <p:cNvPr id="55" name="Text 53"/>
+          <p:cNvSpPr txBox="1"/>
+          <p:nvPr/>
+        </p:nvSpPr>
+        <p:spPr>
+          <a:xfrm>
+            <a:off x="548640" y="6345936"/>
+            <a:ext cx="11091672" cy="237744"/>
+          </a:xfrm>
+          <a:prstGeom prst="rect">
+            <a:avLst/>
+          </a:prstGeom>
+          <a:noFill/>
+          <a:ln/>
+        </p:spPr>
+        <p:txBody>
+          <a:bodyPr wrap="square" lIns="0" tIns="0" rIns="0" bIns="0" rtlCol="0" anchor="ctr"/>
+          <a:lstStyle/>
+          <a:p>
+            <a:pPr indent="0" marL="0">
+              <a:buNone/>
+            </a:pPr>
+            <a:r>
+              <a:rPr lang="en-US" sz="1150" i="1" dirty="0">
+                <a:solidFill>
+                  <a:srgbClr val="8C3A2B"/>
+                </a:solidFill>
+                <a:latin typeface="Cambria" pitchFamily="34" charset="0"/>
+                <a:ea typeface="Cambria" pitchFamily="34" charset="-122"/>
+                <a:cs typeface="Cambria" pitchFamily="34" charset="-120"/>
+              </a:rPr>
+              <a:t>Uzlaşmak zorunda değilsiniz. Ayrıştığınız bir konuyu sunumda açıkça söyleyin — “biz burada anlaşamadık, çünkü…”</a:t>
+            </a:r>
+            <a:endParaRPr lang="en-US" sz="1150" dirty="0"/>
+          </a:p>
+        </p:txBody>
+      </p:sp>
+    </p:spTree>
+  </p:cSld>
+  <p:clrMapOvr>
+    <a:masterClrMapping/>
+  </p:clrMapOvr>
+</p:sld>
+</file>
+
+<file path=ppt/slides/slide3.xml><?xml version="1.0" encoding="utf-8"?>
+<p:sld xmlns:a="http://schemas.openxmlformats.org/drawingml/2006/main" xmlns:r="http://schemas.openxmlformats.org/officeDocument/2006/relationships" xmlns:p="http://schemas.openxmlformats.org/presentationml/2006/main">
+  <p:cSld name="Slide 3">
+    <p:bg>
+      <p:bgPr>
+        <a:solidFill>
+          <a:srgbClr val="FCFCFA"/>
+        </a:solidFill>
+      </p:bgPr>
+    </p:bg>
+    <p:spTree>
+      <p:nvGrpSpPr>
+        <p:cNvPr id="1" name=""/>
+        <p:cNvGrpSpPr/>
+        <p:nvPr/>
+      </p:nvGrpSpPr>
+      <p:grpSpPr>
+        <a:xfrm>
+          <a:off x="0" y="0"/>
+          <a:ext cx="0" cy="0"/>
+          <a:chOff x="0" y="0"/>
+          <a:chExt cx="0" cy="0"/>
+        </a:xfrm>
+      </p:grpSpPr>
+      <p:sp>
+        <p:nvSpPr>
+          <p:cNvPr id="2" name="Text 0"/>
+          <p:cNvSpPr txBox="1"/>
+          <p:nvPr/>
+        </p:nvSpPr>
+        <p:spPr>
+          <a:xfrm>
+            <a:off x="548640" y="292608"/>
+            <a:ext cx="7315200" cy="457200"/>
+          </a:xfrm>
+          <a:prstGeom prst="rect">
+            <a:avLst/>
+          </a:prstGeom>
+          <a:noFill/>
+          <a:ln/>
+        </p:spPr>
+        <p:txBody>
+          <a:bodyPr wrap="square" lIns="0" tIns="0" rIns="0" bIns="0" rtlCol="0" anchor="ctr"/>
+          <a:lstStyle/>
+          <a:p>
+            <a:pPr indent="0" marL="0">
+              <a:buNone/>
+            </a:pPr>
+            <a:r>
+              <a:rPr lang="en-US" sz="2400" b="1" dirty="0">
+                <a:solidFill>
+                  <a:srgbClr val="16161A"/>
+                </a:solidFill>
+                <a:latin typeface="Cambria" pitchFamily="34" charset="0"/>
+                <a:ea typeface="Cambria" pitchFamily="34" charset="-122"/>
+                <a:cs typeface="Cambria" pitchFamily="34" charset="-120"/>
+              </a:rPr>
+              <a:t>Egzersizi yönetme notu</a:t>
+            </a:r>
+            <a:endParaRPr lang="en-US" sz="2400" dirty="0"/>
+          </a:p>
+        </p:txBody>
+      </p:sp>
+      <p:sp>
+        <p:nvSpPr>
+          <p:cNvPr id="3" name="Text 1"/>
+          <p:cNvSpPr txBox="1"/>
+          <p:nvPr/>
+        </p:nvSpPr>
+        <p:spPr>
+          <a:xfrm>
+            <a:off x="548640" y="749808"/>
+            <a:ext cx="8229600" cy="256032"/>
+          </a:xfrm>
+          <a:prstGeom prst="rect">
+            <a:avLst/>
+          </a:prstGeom>
+          <a:noFill/>
+          <a:ln/>
+        </p:spPr>
+        <p:txBody>
+          <a:bodyPr wrap="square" lIns="0" tIns="0" rIns="0" bIns="0" rtlCol="0" anchor="ctr"/>
+          <a:lstStyle/>
+          <a:p>
+            <a:pPr indent="0" marL="0">
+              <a:buNone/>
+            </a:pPr>
+            <a:r>
+              <a:rPr lang="en-US" sz="1050" dirty="0">
+                <a:solidFill>
+                  <a:srgbClr val="7A7A82"/>
+                </a:solidFill>
+                <a:latin typeface="Calibri" pitchFamily="34" charset="0"/>
+                <a:ea typeface="Calibri" pitchFamily="34" charset="-122"/>
+                <a:cs typeface="Calibri" pitchFamily="34" charset="-120"/>
+              </a:rPr>
+              <a:t>Mağaza okuma  ·  bireysel 35 dk + grup 45 dk + sunum 25 dk  =  ~105 dakika</a:t>
+            </a:r>
+            <a:endParaRPr lang="en-US" sz="1050" dirty="0"/>
+          </a:p>
+        </p:txBody>
+      </p:sp>
+      <p:sp>
+        <p:nvSpPr>
+          <p:cNvPr id="4" name="Text 2"/>
+          <p:cNvSpPr txBox="1"/>
+          <p:nvPr/>
+        </p:nvSpPr>
+        <p:spPr>
+          <a:xfrm>
+            <a:off x="548640" y="1207008"/>
+            <a:ext cx="5120640" cy="237744"/>
+          </a:xfrm>
+          <a:prstGeom prst="rect">
+            <a:avLst/>
+          </a:prstGeom>
+          <a:noFill/>
+          <a:ln/>
+        </p:spPr>
+        <p:txBody>
+          <a:bodyPr wrap="square" lIns="0" tIns="0" rIns="0" bIns="0" rtlCol="0" anchor="ctr"/>
+          <a:lstStyle/>
+          <a:p>
+            <a:pPr indent="0" marL="0">
+              <a:buNone/>
+            </a:pPr>
+            <a:r>
+              <a:rPr lang="en-US" sz="900" b="1" spc="160" kern="0" dirty="0">
+                <a:solidFill>
+                  <a:srgbClr val="8C3A2B"/>
+                </a:solidFill>
+                <a:latin typeface="Calibri" pitchFamily="34" charset="0"/>
+                <a:ea typeface="Calibri" pitchFamily="34" charset="-122"/>
+                <a:cs typeface="Calibri" pitchFamily="34" charset="-120"/>
+              </a:rPr>
+              <a:t>GÖRSEL SEÇİM KRİTERLERİ</a:t>
+            </a:r>
+            <a:endParaRPr lang="en-US" sz="900" dirty="0"/>
+          </a:p>
+        </p:txBody>
+      </p:sp>
+      <p:sp>
+        <p:nvSpPr>
+          <p:cNvPr id="5" name="Shape 3"/>
+          <p:cNvSpPr/>
+          <p:nvPr/>
+        </p:nvSpPr>
+        <p:spPr>
+          <a:xfrm>
+            <a:off x="612648" y="1508760"/>
             <a:ext cx="91440" cy="91440"/>
           </a:xfrm>
           <a:prstGeom prst="ellipse">
@@ -3249,8 +5152,8 @@
         </p:nvSpPr>
         <p:spPr>
           <a:xfrm>
-            <a:off x="868680" y="1463040"/>
-            <a:ext cx="4846320" cy="457200"/>
+            <a:off x="868680" y="1426464"/>
+            <a:ext cx="4846320" cy="512064"/>
           </a:xfrm>
           <a:prstGeom prst="rect">
             <a:avLst/>
@@ -3291,7 +5194,7 @@
         </p:nvSpPr>
         <p:spPr>
           <a:xfrm>
-            <a:off x="612648" y="2057400"/>
+            <a:off x="612648" y="2039112"/>
             <a:ext cx="91440" cy="91440"/>
           </a:xfrm>
           <a:prstGeom prst="ellipse">
@@ -3316,8 +5219,8 @@
         </p:nvSpPr>
         <p:spPr>
           <a:xfrm>
-            <a:off x="868680" y="1975104"/>
-            <a:ext cx="4846320" cy="457200"/>
+            <a:off x="868680" y="1956816"/>
+            <a:ext cx="4846320" cy="512064"/>
           </a:xfrm>
           <a:prstGeom prst="rect">
             <a:avLst/>
@@ -3384,7 +5287,7 @@
         <p:spPr>
           <a:xfrm>
             <a:off x="868680" y="2487168"/>
-            <a:ext cx="4846320" cy="457200"/>
+            <a:ext cx="4846320" cy="512064"/>
           </a:xfrm>
           <a:prstGeom prst="rect">
             <a:avLst/>
@@ -3411,7 +5314,7 @@
                 <a:ea typeface="Calibri" pitchFamily="34" charset="-122"/>
                 <a:cs typeface="Calibri" pitchFamily="34" charset="-120"/>
               </a:rPr>
-              <a:t>Logoyu ve tabelayı kırpın. Marka adı görünmesin — mekânı okumak zorunda kalsınlar.</a:t>
+              <a:t>Logoyu ve tabelayı kırpın. Marka adı görünmesin.</a:t>
             </a:r>
             <a:endParaRPr lang="en-US" sz="1050" dirty="0"/>
           </a:p>
@@ -3425,7 +5328,7 @@
         </p:nvSpPr>
         <p:spPr>
           <a:xfrm>
-            <a:off x="612648" y="3081528"/>
+            <a:off x="612648" y="3099816"/>
             <a:ext cx="91440" cy="91440"/>
           </a:xfrm>
           <a:prstGeom prst="ellipse">
@@ -3450,8 +5353,8 @@
         </p:nvSpPr>
         <p:spPr>
           <a:xfrm>
-            <a:off x="868680" y="2999232"/>
-            <a:ext cx="4846320" cy="457200"/>
+            <a:off x="868680" y="3017520"/>
+            <a:ext cx="4846320" cy="512064"/>
           </a:xfrm>
           <a:prstGeom prst="rect">
             <a:avLst/>
@@ -3492,7 +5395,7 @@
         </p:nvSpPr>
         <p:spPr>
           <a:xfrm>
-            <a:off x="612648" y="3593592"/>
+            <a:off x="612648" y="3630168"/>
             <a:ext cx="91440" cy="91440"/>
           </a:xfrm>
           <a:prstGeom prst="ellipse">
@@ -3517,8 +5420,8 @@
         </p:nvSpPr>
         <p:spPr>
           <a:xfrm>
-            <a:off x="868680" y="3511296"/>
-            <a:ext cx="4846320" cy="457200"/>
+            <a:off x="868680" y="3547872"/>
+            <a:ext cx="4846320" cy="512064"/>
           </a:xfrm>
           <a:prstGeom prst="rect">
             <a:avLst/>
@@ -3545,7 +5448,7 @@
                 <a:ea typeface="Calibri" pitchFamily="34" charset="-122"/>
                 <a:cs typeface="Calibri" pitchFamily="34" charset="-120"/>
               </a:rPr>
-              <a:t>Görseli numaralandırın (1–4) ve kâğıdın üstüne numarayı yazdırın.</a:t>
+              <a:t>Görselleri 1–4 numaralandırın; dağıtımı siz yapın, seçtirmeyin.</a:t>
             </a:r>
             <a:endParaRPr lang="en-US" sz="1050" dirty="0"/>
           </a:p>
@@ -3559,7 +5462,7 @@
         </p:nvSpPr>
         <p:spPr>
           <a:xfrm>
-            <a:off x="6309360" y="1234440"/>
+            <a:off x="6309360" y="1207008"/>
             <a:ext cx="5303520" cy="237744"/>
           </a:xfrm>
           <a:prstGeom prst="rect">
@@ -3598,7 +5501,7 @@
         </p:nvSpPr>
         <p:spPr>
           <a:xfrm>
-            <a:off x="6309360" y="1499616"/>
+            <a:off x="6309360" y="1463040"/>
             <a:ext cx="685800" cy="274320"/>
           </a:xfrm>
           <a:prstGeom prst="rect">
@@ -3637,8 +5540,8 @@
         </p:nvSpPr>
         <p:spPr>
           <a:xfrm>
-            <a:off x="7086600" y="1463040"/>
-            <a:ext cx="4553712" cy="457200"/>
+            <a:off x="7086600" y="1426464"/>
+            <a:ext cx="4553712" cy="512064"/>
           </a:xfrm>
           <a:prstGeom prst="rect">
             <a:avLst/>
@@ -3665,7 +5568,7 @@
                 <a:ea typeface="Calibri" pitchFamily="34" charset="-122"/>
                 <a:cs typeface="Calibri" pitchFamily="34" charset="-120"/>
               </a:rPr>
-              <a:t>Yönerge + birlikte bir örnek. Beşinci bir görseli ekrana yansıtıp iki kutuyu sınıfla doldurun.</a:t>
+              <a:t>Yönerge. Beşinci bir görseli ekrana yansıtıp iki kutuyu sınıfla birlikte doldurun.</a:t>
             </a:r>
             <a:endParaRPr lang="en-US" sz="1050" dirty="0"/>
           </a:p>
@@ -3679,7 +5582,7 @@
         </p:nvSpPr>
         <p:spPr>
           <a:xfrm>
-            <a:off x="6309360" y="2011680"/>
+            <a:off x="6309360" y="1993392"/>
             <a:ext cx="685800" cy="274320"/>
           </a:xfrm>
           <a:prstGeom prst="rect">
@@ -3718,8 +5621,8 @@
         </p:nvSpPr>
         <p:spPr>
           <a:xfrm>
-            <a:off x="7086600" y="1975104"/>
-            <a:ext cx="4553712" cy="457200"/>
+            <a:off x="7086600" y="1956816"/>
+            <a:ext cx="4553712" cy="512064"/>
           </a:xfrm>
           <a:prstGeom prst="rect">
             <a:avLst/>
@@ -3746,7 +5649,7 @@
                 <a:ea typeface="Calibri" pitchFamily="34" charset="-122"/>
                 <a:cs typeface="Calibri" pitchFamily="34" charset="-120"/>
               </a:rPr>
-              <a:t>Bireysel ve sessiz çalışma. Konuşma yok, telefon yok, arama yok.</a:t>
+              <a:t>Bireysel ve sessiz. Konuşma yok, telefon yok, arama yok.</a:t>
             </a:r>
             <a:endParaRPr lang="en-US" sz="1050" dirty="0"/>
           </a:p>
@@ -3785,7 +5688,7 @@
                 <a:ea typeface="Calibri" pitchFamily="34" charset="-122"/>
                 <a:cs typeface="Calibri" pitchFamily="34" charset="-120"/>
               </a:rPr>
-              <a:t>10 dk</a:t>
+              <a:t>45 dk</a:t>
             </a:r>
             <a:endParaRPr lang="en-US" sz="1000" dirty="0"/>
           </a:p>
@@ -3800,7 +5703,7 @@
         <p:spPr>
           <a:xfrm>
             <a:off x="7086600" y="2487168"/>
-            <a:ext cx="4553712" cy="457200"/>
+            <a:ext cx="4553712" cy="512064"/>
           </a:xfrm>
           <a:prstGeom prst="rect">
             <a:avLst/>
@@ -3827,7 +5730,7 @@
                 <a:ea typeface="Calibri" pitchFamily="34" charset="-122"/>
                 <a:cs typeface="Calibri" pitchFamily="34" charset="-120"/>
               </a:rPr>
-              <a:t>Aynı görseli alanlar dörtlü gruplaşır ve karşılaştırır. Anlaşamadıkları yer asıl konudur.</a:t>
+              <a:t>Grup çalışması: ayrışma haritası, on iki kelimeden üçe, tek müdahale.</a:t>
             </a:r>
             <a:endParaRPr lang="en-US" sz="1050" dirty="0"/>
           </a:p>
@@ -3841,7 +5744,7 @@
         </p:nvSpPr>
         <p:spPr>
           <a:xfrm>
-            <a:off x="6309360" y="3035808"/>
+            <a:off x="6309360" y="3054096"/>
             <a:ext cx="685800" cy="274320"/>
           </a:xfrm>
           <a:prstGeom prst="rect">
@@ -3880,8 +5783,8 @@
         </p:nvSpPr>
         <p:spPr>
           <a:xfrm>
-            <a:off x="7086600" y="2999232"/>
-            <a:ext cx="4553712" cy="457200"/>
+            <a:off x="7086600" y="3017520"/>
+            <a:ext cx="4553712" cy="512064"/>
           </a:xfrm>
           <a:prstGeom prst="rect">
             <a:avLst/>
@@ -3908,7 +5811,7 @@
                 <a:ea typeface="Calibri" pitchFamily="34" charset="-122"/>
                 <a:cs typeface="Calibri" pitchFamily="34" charset="-120"/>
               </a:rPr>
-              <a:t>Dört grup sırayla görselini sınıfa anlatır — beşer dakika.</a:t>
+              <a:t>Dört grup sırayla anlatır — beşer dakika.</a:t>
             </a:r>
             <a:endParaRPr lang="en-US" sz="1050" dirty="0"/>
           </a:p>
@@ -3922,7 +5825,7 @@
         </p:nvSpPr>
         <p:spPr>
           <a:xfrm>
-            <a:off x="6309360" y="3547872"/>
+            <a:off x="6309360" y="3584448"/>
             <a:ext cx="685800" cy="274320"/>
           </a:xfrm>
           <a:prstGeom prst="rect">
@@ -3947,7 +5850,7 @@
                 <a:ea typeface="Calibri" pitchFamily="34" charset="-122"/>
                 <a:cs typeface="Calibri" pitchFamily="34" charset="-120"/>
               </a:rPr>
-              <a:t>10 dk</a:t>
+              <a:t>5 dk</a:t>
             </a:r>
             <a:endParaRPr lang="en-US" sz="1000" dirty="0"/>
           </a:p>
@@ -3961,8 +5864,8 @@
         </p:nvSpPr>
         <p:spPr>
           <a:xfrm>
-            <a:off x="7086600" y="3511296"/>
-            <a:ext cx="4553712" cy="457200"/>
+            <a:off x="7086600" y="3547872"/>
+            <a:ext cx="4553712" cy="512064"/>
           </a:xfrm>
           <a:prstGeom prst="rect">
             <a:avLst/>
@@ -4026,7 +5929,7 @@
         </p:nvSpPr>
         <p:spPr>
           <a:xfrm>
-            <a:off x="548640" y="4370832"/>
+            <a:off x="548640" y="4352544"/>
             <a:ext cx="5120640" cy="237744"/>
           </a:xfrm>
           <a:prstGeom prst="rect">
@@ -4051,7 +5954,7 @@
                 <a:ea typeface="Calibri" pitchFamily="34" charset="-122"/>
                 <a:cs typeface="Calibri" pitchFamily="34" charset="-120"/>
               </a:rPr>
-              <a:t>ÖRNEK DOLDURULMUŞ SATIR</a:t>
+              <a:t>GRUP AŞAMASINDA DİKKAT</a:t>
             </a:r>
             <a:endParaRPr lang="en-US" sz="900" dirty="0"/>
           </a:p>
@@ -4066,23 +5969,65 @@
         <p:spPr>
           <a:xfrm>
             <a:off x="548640" y="4626864"/>
-            <a:ext cx="5120640" cy="256032"/>
-          </a:xfrm>
-          <a:prstGeom prst="rect">
-            <a:avLst/>
-          </a:prstGeom>
-          <a:noFill/>
-          <a:ln/>
-        </p:spPr>
-        <p:txBody>
-          <a:bodyPr wrap="square" lIns="0" tIns="0" rIns="0" bIns="0" rtlCol="0" anchor="ctr"/>
-          <a:lstStyle/>
-          <a:p>
-            <a:pPr indent="0" marL="0">
-              <a:buNone/>
-            </a:pPr>
-            <a:r>
-              <a:rPr lang="en-US" sz="1050" i="1" dirty="0">
+            <a:ext cx="5330952" cy="219456"/>
+          </a:xfrm>
+          <a:prstGeom prst="rect">
+            <a:avLst/>
+          </a:prstGeom>
+          <a:noFill/>
+          <a:ln/>
+        </p:spPr>
+        <p:txBody>
+          <a:bodyPr wrap="square" lIns="0" tIns="0" rIns="0" bIns="0" rtlCol="0" anchor="ctr"/>
+          <a:lstStyle/>
+          <a:p>
+            <a:pPr indent="0" marL="0">
+              <a:buNone/>
+            </a:pPr>
+            <a:r>
+              <a:rPr lang="en-US" sz="1050" b="1" dirty="0">
+                <a:solidFill>
+                  <a:srgbClr val="16161A"/>
+                </a:solidFill>
+                <a:latin typeface="Calibri" pitchFamily="34" charset="0"/>
+                <a:ea typeface="Calibri" pitchFamily="34" charset="-122"/>
+                <a:cs typeface="Calibri" pitchFamily="34" charset="-120"/>
+              </a:rPr>
+              <a:t>Uzlaşmaya zorlamayın.</a:t>
+            </a:r>
+            <a:endParaRPr lang="en-US" sz="1050" dirty="0"/>
+          </a:p>
+        </p:txBody>
+      </p:sp>
+      <p:sp>
+        <p:nvSpPr>
+          <p:cNvPr id="29" name="Text 27"/>
+          <p:cNvSpPr txBox="1"/>
+          <p:nvPr/>
+        </p:nvSpPr>
+        <p:spPr>
+          <a:xfrm>
+            <a:off x="548640" y="4846320"/>
+            <a:ext cx="5330952" cy="475488"/>
+          </a:xfrm>
+          <a:prstGeom prst="rect">
+            <a:avLst/>
+          </a:prstGeom>
+          <a:noFill/>
+          <a:ln/>
+        </p:spPr>
+        <p:txBody>
+          <a:bodyPr wrap="square" lIns="0" tIns="0" rIns="0" bIns="0" rtlCol="0" anchor="ctr"/>
+          <a:lstStyle/>
+          <a:p>
+            <a:pPr indent="0" marL="0">
+              <a:lnSpc>
+                <a:spcPts val="1250"/>
+              </a:lnSpc>
+              <a:buNone/>
+            </a:pPr>
+            <a:r>
+              <a:rPr lang="en-US" sz="1000" dirty="0">
                 <a:solidFill>
                   <a:srgbClr val="7A7A82"/>
                 </a:solidFill>
@@ -4090,7 +6035,46 @@
                 <a:ea typeface="Calibri" pitchFamily="34" charset="-122"/>
                 <a:cs typeface="Calibri" pitchFamily="34" charset="-120"/>
               </a:rPr>
-              <a:t>Bir seramik atölyesi görseli için:</a:t>
+              <a:t>Dört okumayı ortalayan grup en değerli şeyi kaybeder. Ayrışmayı yazmaları yeter; çözmeleri gerekmiyor.</a:t>
+            </a:r>
+            <a:endParaRPr lang="en-US" sz="1000" dirty="0"/>
+          </a:p>
+        </p:txBody>
+      </p:sp>
+      <p:sp>
+        <p:nvSpPr>
+          <p:cNvPr id="30" name="Text 28"/>
+          <p:cNvSpPr txBox="1"/>
+          <p:nvPr/>
+        </p:nvSpPr>
+        <p:spPr>
+          <a:xfrm>
+            <a:off x="6309360" y="4626864"/>
+            <a:ext cx="5330952" cy="219456"/>
+          </a:xfrm>
+          <a:prstGeom prst="rect">
+            <a:avLst/>
+          </a:prstGeom>
+          <a:noFill/>
+          <a:ln/>
+        </p:spPr>
+        <p:txBody>
+          <a:bodyPr wrap="square" lIns="0" tIns="0" rIns="0" bIns="0" rtlCol="0" anchor="ctr"/>
+          <a:lstStyle/>
+          <a:p>
+            <a:pPr indent="0" marL="0">
+              <a:buNone/>
+            </a:pPr>
+            <a:r>
+              <a:rPr lang="en-US" sz="1050" b="1" dirty="0">
+                <a:solidFill>
+                  <a:srgbClr val="16161A"/>
+                </a:solidFill>
+                <a:latin typeface="Calibri" pitchFamily="34" charset="0"/>
+                <a:ea typeface="Calibri" pitchFamily="34" charset="-122"/>
+                <a:cs typeface="Calibri" pitchFamily="34" charset="-120"/>
+              </a:rPr>
+              <a:t>Kalemi en az konuşana verin.</a:t>
             </a:r>
             <a:endParaRPr lang="en-US" sz="1050" dirty="0"/>
           </a:p>
@@ -4098,53 +6082,218 @@
       </p:sp>
       <p:sp>
         <p:nvSpPr>
-          <p:cNvPr id="29" name="Text 27"/>
-          <p:cNvSpPr txBox="1"/>
-          <p:nvPr/>
-        </p:nvSpPr>
-        <p:spPr>
-          <a:xfrm>
-            <a:off x="548640" y="4956048"/>
-            <a:ext cx="1600200" cy="274320"/>
-          </a:xfrm>
-          <a:prstGeom prst="rect">
-            <a:avLst/>
-          </a:prstGeom>
-          <a:noFill/>
-          <a:ln/>
-        </p:spPr>
-        <p:txBody>
-          <a:bodyPr wrap="square" lIns="0" tIns="0" rIns="0" bIns="0" rtlCol="0" anchor="ctr"/>
-          <a:lstStyle/>
-          <a:p>
-            <a:pPr indent="0" marL="0">
-              <a:buNone/>
-            </a:pPr>
-            <a:r>
-              <a:rPr lang="en-US" sz="850" b="1" spc="120" kern="0" dirty="0">
-                <a:solidFill>
-                  <a:srgbClr val="A6A6AC"/>
-                </a:solidFill>
-                <a:latin typeface="Calibri" pitchFamily="34" charset="0"/>
-                <a:ea typeface="Calibri" pitchFamily="34" charset="-122"/>
-                <a:cs typeface="Calibri" pitchFamily="34" charset="-120"/>
-              </a:rPr>
-              <a:t>GÖRDÜĞÜM</a:t>
-            </a:r>
-            <a:endParaRPr lang="en-US" sz="850" dirty="0"/>
-          </a:p>
-        </p:txBody>
-      </p:sp>
-      <p:sp>
-        <p:nvSpPr>
-          <p:cNvPr id="30" name="Text 28"/>
-          <p:cNvSpPr txBox="1"/>
-          <p:nvPr/>
-        </p:nvSpPr>
-        <p:spPr>
-          <a:xfrm>
-            <a:off x="2240280" y="4919472"/>
-            <a:ext cx="9400032" cy="457200"/>
+          <p:cNvPr id="31" name="Text 29"/>
+          <p:cNvSpPr txBox="1"/>
+          <p:nvPr/>
+        </p:nvSpPr>
+        <p:spPr>
+          <a:xfrm>
+            <a:off x="6309360" y="4846320"/>
+            <a:ext cx="5330952" cy="475488"/>
+          </a:xfrm>
+          <a:prstGeom prst="rect">
+            <a:avLst/>
+          </a:prstGeom>
+          <a:noFill/>
+          <a:ln/>
+        </p:spPr>
+        <p:txBody>
+          <a:bodyPr wrap="square" lIns="0" tIns="0" rIns="0" bIns="0" rtlCol="0" anchor="ctr"/>
+          <a:lstStyle/>
+          <a:p>
+            <a:pPr indent="0" marL="0">
+              <a:lnSpc>
+                <a:spcPts val="1250"/>
+              </a:lnSpc>
+              <a:buNone/>
+            </a:pPr>
+            <a:r>
+              <a:rPr lang="en-US" sz="1000" dirty="0">
+                <a:solidFill>
+                  <a:srgbClr val="7A7A82"/>
+                </a:solidFill>
+                <a:latin typeface="Calibri" pitchFamily="34" charset="0"/>
+                <a:ea typeface="Calibri" pitchFamily="34" charset="-122"/>
+                <a:cs typeface="Calibri" pitchFamily="34" charset="-120"/>
+              </a:rPr>
+              <a:t>Yoksa kâğıdı baskın öğrenci doldurur ve diğer üç okuma kaybolur.</a:t>
+            </a:r>
+            <a:endParaRPr lang="en-US" sz="1000" dirty="0"/>
+          </a:p>
+        </p:txBody>
+      </p:sp>
+      <p:sp>
+        <p:nvSpPr>
+          <p:cNvPr id="32" name="Text 30"/>
+          <p:cNvSpPr txBox="1"/>
+          <p:nvPr/>
+        </p:nvSpPr>
+        <p:spPr>
+          <a:xfrm>
+            <a:off x="548640" y="5376672"/>
+            <a:ext cx="5330952" cy="219456"/>
+          </a:xfrm>
+          <a:prstGeom prst="rect">
+            <a:avLst/>
+          </a:prstGeom>
+          <a:noFill/>
+          <a:ln/>
+        </p:spPr>
+        <p:txBody>
+          <a:bodyPr wrap="square" lIns="0" tIns="0" rIns="0" bIns="0" rtlCol="0" anchor="ctr"/>
+          <a:lstStyle/>
+          <a:p>
+            <a:pPr indent="0" marL="0">
+              <a:buNone/>
+            </a:pPr>
+            <a:r>
+              <a:rPr lang="en-US" sz="1050" b="1" dirty="0">
+                <a:solidFill>
+                  <a:srgbClr val="16161A"/>
+                </a:solidFill>
+                <a:latin typeface="Calibri" pitchFamily="34" charset="0"/>
+                <a:ea typeface="Calibri" pitchFamily="34" charset="-122"/>
+                <a:cs typeface="Calibri" pitchFamily="34" charset="-120"/>
+              </a:rPr>
+              <a:t>“Kaliteli” çıkarsa hemen müdahale edin.</a:t>
+            </a:r>
+            <a:endParaRPr lang="en-US" sz="1050" dirty="0"/>
+          </a:p>
+        </p:txBody>
+      </p:sp>
+      <p:sp>
+        <p:nvSpPr>
+          <p:cNvPr id="33" name="Text 31"/>
+          <p:cNvSpPr txBox="1"/>
+          <p:nvPr/>
+        </p:nvSpPr>
+        <p:spPr>
+          <a:xfrm>
+            <a:off x="548640" y="5596128"/>
+            <a:ext cx="5330952" cy="475488"/>
+          </a:xfrm>
+          <a:prstGeom prst="rect">
+            <a:avLst/>
+          </a:prstGeom>
+          <a:noFill/>
+          <a:ln/>
+        </p:spPr>
+        <p:txBody>
+          <a:bodyPr wrap="square" lIns="0" tIns="0" rIns="0" bIns="0" rtlCol="0" anchor="ctr"/>
+          <a:lstStyle/>
+          <a:p>
+            <a:pPr indent="0" marL="0">
+              <a:lnSpc>
+                <a:spcPts val="1250"/>
+              </a:lnSpc>
+              <a:buNone/>
+            </a:pPr>
+            <a:r>
+              <a:rPr lang="en-US" sz="1000" dirty="0">
+                <a:solidFill>
+                  <a:srgbClr val="7A7A82"/>
+                </a:solidFill>
+                <a:latin typeface="Calibri" pitchFamily="34" charset="0"/>
+                <a:ea typeface="Calibri" pitchFamily="34" charset="-122"/>
+                <a:cs typeface="Calibri" pitchFamily="34" charset="-120"/>
+              </a:rPr>
+              <a:t>Havuzda böyle kelimeler olacak; elenme gerekçesini grup sözlü olarak kurmalı.</a:t>
+            </a:r>
+            <a:endParaRPr lang="en-US" sz="1000" dirty="0"/>
+          </a:p>
+        </p:txBody>
+      </p:sp>
+      <p:sp>
+        <p:nvSpPr>
+          <p:cNvPr id="34" name="Text 32"/>
+          <p:cNvSpPr txBox="1"/>
+          <p:nvPr/>
+        </p:nvSpPr>
+        <p:spPr>
+          <a:xfrm>
+            <a:off x="6309360" y="5376672"/>
+            <a:ext cx="5330952" cy="219456"/>
+          </a:xfrm>
+          <a:prstGeom prst="rect">
+            <a:avLst/>
+          </a:prstGeom>
+          <a:noFill/>
+          <a:ln/>
+        </p:spPr>
+        <p:txBody>
+          <a:bodyPr wrap="square" lIns="0" tIns="0" rIns="0" bIns="0" rtlCol="0" anchor="ctr"/>
+          <a:lstStyle/>
+          <a:p>
+            <a:pPr indent="0" marL="0">
+              <a:buNone/>
+            </a:pPr>
+            <a:r>
+              <a:rPr lang="en-US" sz="1050" b="1" dirty="0">
+                <a:solidFill>
+                  <a:srgbClr val="16161A"/>
+                </a:solidFill>
+                <a:latin typeface="Calibri" pitchFamily="34" charset="0"/>
+                <a:ea typeface="Calibri" pitchFamily="34" charset="-122"/>
+                <a:cs typeface="Calibri" pitchFamily="34" charset="-120"/>
+              </a:rPr>
+              <a:t>Müdahale kutusunu küçük tutturun.</a:t>
+            </a:r>
+            <a:endParaRPr lang="en-US" sz="1050" dirty="0"/>
+          </a:p>
+        </p:txBody>
+      </p:sp>
+      <p:sp>
+        <p:nvSpPr>
+          <p:cNvPr id="35" name="Text 33"/>
+          <p:cNvSpPr txBox="1"/>
+          <p:nvPr/>
+        </p:nvSpPr>
+        <p:spPr>
+          <a:xfrm>
+            <a:off x="6309360" y="5596128"/>
+            <a:ext cx="5330952" cy="475488"/>
+          </a:xfrm>
+          <a:prstGeom prst="rect">
+            <a:avLst/>
+          </a:prstGeom>
+          <a:noFill/>
+          <a:ln/>
+        </p:spPr>
+        <p:txBody>
+          <a:bodyPr wrap="square" lIns="0" tIns="0" rIns="0" bIns="0" rtlCol="0" anchor="ctr"/>
+          <a:lstStyle/>
+          <a:p>
+            <a:pPr indent="0" marL="0">
+              <a:lnSpc>
+                <a:spcPts val="1250"/>
+              </a:lnSpc>
+              <a:buNone/>
+            </a:pPr>
+            <a:r>
+              <a:rPr lang="en-US" sz="1000" dirty="0">
+                <a:solidFill>
+                  <a:srgbClr val="7A7A82"/>
+                </a:solidFill>
+                <a:latin typeface="Calibri" pitchFamily="34" charset="0"/>
+                <a:ea typeface="Calibri" pitchFamily="34" charset="-122"/>
+                <a:cs typeface="Calibri" pitchFamily="34" charset="-120"/>
+              </a:rPr>
+              <a:t>Amaç tasarlamak değil, analizin bir karara bağlanabildiğini görmek. Tek cümle + kaba eskiz yeter.</a:t>
+            </a:r>
+            <a:endParaRPr lang="en-US" sz="1000" dirty="0"/>
+          </a:p>
+        </p:txBody>
+      </p:sp>
+      <p:sp>
+        <p:nvSpPr>
+          <p:cNvPr id="36" name="Text 34"/>
+          <p:cNvSpPr txBox="1"/>
+          <p:nvPr/>
+        </p:nvSpPr>
+        <p:spPr>
+          <a:xfrm>
+            <a:off x="548640" y="6272784"/>
+            <a:ext cx="11091672" cy="365760"/>
           </a:xfrm>
           <a:prstGeom prst="rect">
             <a:avLst/>
@@ -4163,219 +6312,15 @@
               <a:buNone/>
             </a:pPr>
             <a:r>
-              <a:rPr lang="en-US" sz="1200" dirty="0">
-                <a:solidFill>
-                  <a:srgbClr val="2B2B31"/>
+              <a:rPr lang="en-US" sz="1200" i="1" dirty="0">
+                <a:solidFill>
+                  <a:srgbClr val="8C3A2B"/>
                 </a:solidFill>
                 <a:latin typeface="Cambria" pitchFamily="34" charset="0"/>
                 <a:ea typeface="Cambria" pitchFamily="34" charset="-122"/>
                 <a:cs typeface="Cambria" pitchFamily="34" charset="-120"/>
               </a:rPr>
-              <a:t>Ürünler tek tek, aralarında 30–40 cm boşlukla duruyor. Her parçanın üstünde ayrı bir nokta ışık var. Raf sayısı az.</a:t>
-            </a:r>
-            <a:endParaRPr lang="en-US" sz="1200" dirty="0"/>
-          </a:p>
-        </p:txBody>
-      </p:sp>
-      <p:sp>
-        <p:nvSpPr>
-          <p:cNvPr id="31" name="Text 29"/>
-          <p:cNvSpPr txBox="1"/>
-          <p:nvPr/>
-        </p:nvSpPr>
-        <p:spPr>
-          <a:xfrm>
-            <a:off x="548640" y="5413248"/>
-            <a:ext cx="1600200" cy="274320"/>
-          </a:xfrm>
-          <a:prstGeom prst="rect">
-            <a:avLst/>
-          </a:prstGeom>
-          <a:noFill/>
-          <a:ln/>
-        </p:spPr>
-        <p:txBody>
-          <a:bodyPr wrap="square" lIns="0" tIns="0" rIns="0" bIns="0" rtlCol="0" anchor="ctr"/>
-          <a:lstStyle/>
-          <a:p>
-            <a:pPr indent="0" marL="0">
-              <a:buNone/>
-            </a:pPr>
-            <a:r>
-              <a:rPr lang="en-US" sz="850" b="1" spc="120" kern="0" dirty="0">
-                <a:solidFill>
-                  <a:srgbClr val="A6A6AC"/>
-                </a:solidFill>
-                <a:latin typeface="Calibri" pitchFamily="34" charset="0"/>
-                <a:ea typeface="Calibri" pitchFamily="34" charset="-122"/>
-                <a:cs typeface="Calibri" pitchFamily="34" charset="-120"/>
-              </a:rPr>
-              <a:t>ÇIKARDIĞIM</a:t>
-            </a:r>
-            <a:endParaRPr lang="en-US" sz="850" dirty="0"/>
-          </a:p>
-        </p:txBody>
-      </p:sp>
-      <p:sp>
-        <p:nvSpPr>
-          <p:cNvPr id="32" name="Text 30"/>
-          <p:cNvSpPr txBox="1"/>
-          <p:nvPr/>
-        </p:nvSpPr>
-        <p:spPr>
-          <a:xfrm>
-            <a:off x="2240280" y="5376672"/>
-            <a:ext cx="9400032" cy="457200"/>
-          </a:xfrm>
-          <a:prstGeom prst="rect">
-            <a:avLst/>
-          </a:prstGeom>
-          <a:noFill/>
-          <a:ln/>
-        </p:spPr>
-        <p:txBody>
-          <a:bodyPr wrap="square" lIns="0" tIns="0" rIns="0" bIns="0" rtlCol="0" anchor="ctr"/>
-          <a:lstStyle/>
-          <a:p>
-            <a:pPr indent="0" marL="0">
-              <a:lnSpc>
-                <a:spcPts val="1600"/>
-              </a:lnSpc>
-              <a:buNone/>
-            </a:pPr>
-            <a:r>
-              <a:rPr lang="en-US" sz="1200" dirty="0">
-                <a:solidFill>
-                  <a:srgbClr val="2B2B31"/>
-                </a:solidFill>
-                <a:latin typeface="Cambria" pitchFamily="34" charset="0"/>
-                <a:ea typeface="Cambria" pitchFamily="34" charset="-122"/>
-                <a:cs typeface="Cambria" pitchFamily="34" charset="-120"/>
-              </a:rPr>
-              <a:t>Ürünler birbirinin aynısı değil; her biri tekil. Marka “el yapımı” iddiasında ve bunu yoğunluk düşürerek kanıtlıyor.</a:t>
-            </a:r>
-            <a:endParaRPr lang="en-US" sz="1200" dirty="0"/>
-          </a:p>
-        </p:txBody>
-      </p:sp>
-      <p:sp>
-        <p:nvSpPr>
-          <p:cNvPr id="33" name="Text 31"/>
-          <p:cNvSpPr txBox="1"/>
-          <p:nvPr/>
-        </p:nvSpPr>
-        <p:spPr>
-          <a:xfrm>
-            <a:off x="548640" y="5870448"/>
-            <a:ext cx="1600200" cy="274320"/>
-          </a:xfrm>
-          <a:prstGeom prst="rect">
-            <a:avLst/>
-          </a:prstGeom>
-          <a:noFill/>
-          <a:ln/>
-        </p:spPr>
-        <p:txBody>
-          <a:bodyPr wrap="square" lIns="0" tIns="0" rIns="0" bIns="0" rtlCol="0" anchor="ctr"/>
-          <a:lstStyle/>
-          <a:p>
-            <a:pPr indent="0" marL="0">
-              <a:buNone/>
-            </a:pPr>
-            <a:r>
-              <a:rPr lang="en-US" sz="850" b="1" spc="120" kern="0" dirty="0">
-                <a:solidFill>
-                  <a:srgbClr val="A6A6AC"/>
-                </a:solidFill>
-                <a:latin typeface="Calibri" pitchFamily="34" charset="0"/>
-                <a:ea typeface="Calibri" pitchFamily="34" charset="-122"/>
-                <a:cs typeface="Calibri" pitchFamily="34" charset="-120"/>
-              </a:rPr>
-              <a:t>ANAHTAR KELİME</a:t>
-            </a:r>
-            <a:endParaRPr lang="en-US" sz="850" dirty="0"/>
-          </a:p>
-        </p:txBody>
-      </p:sp>
-      <p:sp>
-        <p:nvSpPr>
-          <p:cNvPr id="34" name="Text 32"/>
-          <p:cNvSpPr txBox="1"/>
-          <p:nvPr/>
-        </p:nvSpPr>
-        <p:spPr>
-          <a:xfrm>
-            <a:off x="2240280" y="5833872"/>
-            <a:ext cx="9400032" cy="457200"/>
-          </a:xfrm>
-          <a:prstGeom prst="rect">
-            <a:avLst/>
-          </a:prstGeom>
-          <a:noFill/>
-          <a:ln/>
-        </p:spPr>
-        <p:txBody>
-          <a:bodyPr wrap="square" lIns="0" tIns="0" rIns="0" bIns="0" rtlCol="0" anchor="ctr"/>
-          <a:lstStyle/>
-          <a:p>
-            <a:pPr indent="0" marL="0">
-              <a:lnSpc>
-                <a:spcPts val="1600"/>
-              </a:lnSpc>
-              <a:buNone/>
-            </a:pPr>
-            <a:r>
-              <a:rPr lang="en-US" sz="1200" dirty="0">
-                <a:solidFill>
-                  <a:srgbClr val="2B2B31"/>
-                </a:solidFill>
-                <a:latin typeface="Cambria" pitchFamily="34" charset="0"/>
-                <a:ea typeface="Cambria" pitchFamily="34" charset="-122"/>
-                <a:cs typeface="Cambria" pitchFamily="34" charset="-120"/>
-              </a:rPr>
-              <a:t>TEKİLLİK  —  kanıt: ürünler arası boşluk ve parça başına ayrı aydınlatma.</a:t>
-            </a:r>
-            <a:endParaRPr lang="en-US" sz="1200" dirty="0"/>
-          </a:p>
-        </p:txBody>
-      </p:sp>
-      <p:sp>
-        <p:nvSpPr>
-          <p:cNvPr id="35" name="Text 33"/>
-          <p:cNvSpPr txBox="1"/>
-          <p:nvPr/>
-        </p:nvSpPr>
-        <p:spPr>
-          <a:xfrm>
-            <a:off x="548640" y="6382512"/>
-            <a:ext cx="11091672" cy="365760"/>
-          </a:xfrm>
-          <a:prstGeom prst="rect">
-            <a:avLst/>
-          </a:prstGeom>
-          <a:noFill/>
-          <a:ln/>
-        </p:spPr>
-        <p:txBody>
-          <a:bodyPr wrap="square" lIns="0" tIns="0" rIns="0" bIns="0" rtlCol="0" anchor="ctr"/>
-          <a:lstStyle/>
-          <a:p>
-            <a:pPr indent="0" marL="0">
-              <a:lnSpc>
-                <a:spcPts val="1600"/>
-              </a:lnSpc>
-              <a:buNone/>
-            </a:pPr>
-            <a:r>
-              <a:rPr lang="en-US" sz="1200" i="1" dirty="0">
-                <a:solidFill>
-                  <a:srgbClr val="8C3A2B"/>
-                </a:solidFill>
-                <a:latin typeface="Cambria" pitchFamily="34" charset="0"/>
-                <a:ea typeface="Cambria" pitchFamily="34" charset="-122"/>
-                <a:cs typeface="Cambria" pitchFamily="34" charset="-120"/>
-              </a:rPr>
-              <a:t>En sık görülen hata: kanıtsız çıkarım. “Lüks bir marka” yazıp geçmek. Her çıkarımın yanında görseldeki dayanağını isteyin — bu alışkanlık dönem boyunca işinize yarayacak.</a:t>
+              <a:t>En sık görülen hata kanıtsız çıkarımdır: “lüks bir marka” yazıp geçmek. Her çıkarımın yanında görseldeki dayanağını isteyin.</a:t>
             </a:r>
             <a:endParaRPr lang="en-US" sz="1200" dirty="0"/>
           </a:p>

</xml_diff>